<commit_message>
Update 25-Slide Master Deck with combined Multimodal Hardware Slide 13 and dedicated BERT, SHAP XAI, and PHQ/MHQ slides
</commit_message>
<xml_diff>
--- a/Final_Submission_Pack/KEFFI_PURE_WHITE_TIMES_ROMAN_25_SLIDE_MASTER.pptx
+++ b/Final_Submission_Pack/KEFFI_PURE_WHITE_TIMES_ROMAN_25_SLIDE_MASTER.pptx
@@ -3405,15 +3405,15 @@
           <a:lstStyle/>
           <a:p>
             <a:pPr>
-              <a:defRPr sz="2800" b="1">
-                <a:solidFill>
-                  <a:srgbClr val="000000"/>
-                </a:solidFill>
-                <a:latin typeface="Times New Roman"/>
-              </a:defRPr>
-            </a:pPr>
-            <a:r>
-              <a:t>96-STATE CLINICAL EMOTION MODEL</a:t>
+              <a:defRPr sz="2400" b="1">
+                <a:solidFill>
+                  <a:srgbClr val="000000"/>
+                </a:solidFill>
+                <a:latin typeface="Times New Roman"/>
+              </a:defRPr>
+            </a:pPr>
+            <a:r>
+              <a:t>DEDICATED BERT TRANSFORMER NLP ENGINE (96-STATE TAXONOMY)</a:t>
             </a:r>
           </a:p>
         </p:txBody>
@@ -3452,23 +3452,23 @@
               </a:defRPr>
             </a:pPr>
             <a:r>
-              <a:t>Fine-Tuned BERT Transformer Model</a:t>
-            </a:r>
-          </a:p>
-          <a:p>
-            <a:pPr>
-              <a:spcAft>
-                <a:spcPts val="800"/>
-              </a:spcAft>
-              <a:defRPr sz="1800" b="0">
-                <a:solidFill>
-                  <a:srgbClr val="000000"/>
-                </a:solidFill>
-                <a:latin typeface="Times New Roman"/>
-              </a:defRPr>
-            </a:pPr>
-            <a:r>
-              <a:t>Custom fine-tuned BERT transformer architecture trained to classify patient inputs across 96 clinically relevant emotional states rather than basic positive/negative labels.</a:t>
+              <a:t>Fine-Tuned BERT Transformer Architecture:</a:t>
+            </a:r>
+          </a:p>
+          <a:p>
+            <a:pPr>
+              <a:spcAft>
+                <a:spcPts val="800"/>
+              </a:spcAft>
+              <a:defRPr sz="1800" b="0">
+                <a:solidFill>
+                  <a:srgbClr val="000000"/>
+                </a:solidFill>
+                <a:latin typeface="Times New Roman"/>
+              </a:defRPr>
+            </a:pPr>
+            <a:r>
+              <a:t>Custom deep learning transformer model fine-tuned on clinical transcripts to classify patient text across a comprehensive 96-state clinical emotion taxonomy.</a:t>
             </a:r>
           </a:p>
           <a:p>
@@ -3497,7 +3497,7 @@
               </a:defRPr>
             </a:pPr>
             <a:r>
-              <a:t>Comprehensive Clinical Taxonomy:</a:t>
+              <a:t>96-State Taxonomy Breakdown:</a:t>
             </a:r>
           </a:p>
           <a:p>
@@ -3590,7 +3590,7 @@
               </a:defRPr>
             </a:pPr>
             <a:r>
-              <a:t>High Classification Efficacy: Achieved 94.8% F1-score accuracy evaluated against benchmark clinical transcripts.</a:t>
+              <a:t>Diagnostic Precision: Achieved 94.8% F1-score accuracy evaluated against benchmark clinical psychiatric transcripts.</a:t>
             </a:r>
           </a:p>
         </p:txBody>
@@ -3727,23 +3727,23 @@
               </a:defRPr>
             </a:pPr>
             <a:r>
-              <a:t>41 Depression Presentations:</a:t>
-            </a:r>
-          </a:p>
-          <a:p>
-            <a:pPr>
-              <a:spcAft>
-                <a:spcPts val="800"/>
-              </a:spcAft>
-              <a:defRPr sz="1800" b="0">
-                <a:solidFill>
-                  <a:srgbClr val="000000"/>
-                </a:solidFill>
-                <a:latin typeface="Times New Roman"/>
-              </a:defRPr>
-            </a:pPr>
-            <a:r>
-              <a:t>Major Depressive Disorder (MDD), Persistent Depressive Disorder (PDD), Bipolar Swings, Postpartum Depression, Seasonal Affective Disorder (SAD), Smiling Depression, Treatment-Resistant Depression (TRD), Melancholic, Agitated, Psychotic.</a:t>
+              <a:t>41 Depression Sub-Types:</a:t>
+            </a:r>
+          </a:p>
+          <a:p>
+            <a:pPr>
+              <a:spcAft>
+                <a:spcPts val="800"/>
+              </a:spcAft>
+              <a:defRPr sz="1800" b="0">
+                <a:solidFill>
+                  <a:srgbClr val="000000"/>
+                </a:solidFill>
+                <a:latin typeface="Times New Roman"/>
+              </a:defRPr>
+            </a:pPr>
+            <a:r>
+              <a:t>Major Depressive Disorder (MDD), Persistent Depressive Disorder (PDD), Bipolar Swings, Postpartum, SAD, Smiling Depression, Treatment-Resistant Depression (TRD), Melancholic, Agitated, Psychotic.</a:t>
             </a:r>
           </a:p>
           <a:p>
@@ -4190,15 +4190,15 @@
           <a:lstStyle/>
           <a:p>
             <a:pPr>
-              <a:defRPr sz="2800" b="1">
-                <a:solidFill>
-                  <a:srgbClr val="000000"/>
-                </a:solidFill>
-                <a:latin typeface="Times New Roman"/>
-              </a:defRPr>
-            </a:pPr>
-            <a:r>
-              <a:t>FINGERS HD WEBCAM 68-LANDMARK RETICLE ENGINE</a:t>
+              <a:defRPr sz="2400" b="1">
+                <a:solidFill>
+                  <a:srgbClr val="000000"/>
+                </a:solidFill>
+                <a:latin typeface="Times New Roman"/>
+              </a:defRPr>
+            </a:pPr>
+            <a:r>
+              <a:t>MULTIMODAL HARDWARE SENSING &amp; LIVE VIDEO CALL ENGINE</a:t>
             </a:r>
           </a:p>
         </p:txBody>
@@ -4237,23 +4237,23 @@
               </a:defRPr>
             </a:pPr>
             <a:r>
-              <a:t>Real-Time Computer Vision Reticle Scanner:</a:t>
-            </a:r>
-          </a:p>
-          <a:p>
-            <a:pPr>
-              <a:spcAft>
-                <a:spcPts val="800"/>
-              </a:spcAft>
-              <a:defRPr sz="1800" b="0">
-                <a:solidFill>
-                  <a:srgbClr val="000000"/>
-                </a:solidFill>
-                <a:latin typeface="Times New Roman"/>
-              </a:defRPr>
-            </a:pPr>
-            <a:r>
-              <a:t>Uses FINGERS HD Webcam (720p/1080p) to map 68 facial points around eyebrows, eyes, mouth, and jawline.</a:t>
+              <a:t>1. FINGERS HD Webcam 68-Landmark Reticle Scanner:</a:t>
+            </a:r>
+          </a:p>
+          <a:p>
+            <a:pPr>
+              <a:spcAft>
+                <a:spcPts val="800"/>
+              </a:spcAft>
+              <a:defRPr sz="1800" b="0">
+                <a:solidFill>
+                  <a:srgbClr val="000000"/>
+                </a:solidFill>
+                <a:latin typeface="Times New Roman"/>
+              </a:defRPr>
+            </a:pPr>
+            <a:r>
+              <a:t>Maps 68 facial points around eyebrows, eyes, mouth, and jawline. Detects Anxiety/Panic (eyebrow contraction), Depressive Slump (mouth downturn), Anger (jaw clench). Renders enlarged 320x320px HD glass container with glowing green tracking mesh reticle &amp; HUD confidence badge.</a:t>
             </a:r>
           </a:p>
           <a:p>
@@ -4282,100 +4282,68 @@
               </a:defRPr>
             </a:pPr>
             <a:r>
-              <a:t>6 Core Facial Affects Detected:</a:t>
-            </a:r>
-          </a:p>
-          <a:p>
-            <a:pPr>
-              <a:spcAft>
-                <a:spcPts val="800"/>
-              </a:spcAft>
-              <a:defRPr sz="1800" b="0">
-                <a:solidFill>
-                  <a:srgbClr val="000000"/>
-                </a:solidFill>
-                <a:latin typeface="Times New Roman"/>
-              </a:defRPr>
-            </a:pPr>
-            <a:r>
-              <a:t>• Anxiety/Panic: Eyebrow contraction &amp; forehead muscle tension</a:t>
-            </a:r>
-          </a:p>
-          <a:p>
-            <a:pPr>
-              <a:spcAft>
-                <a:spcPts val="800"/>
-              </a:spcAft>
-              <a:defRPr sz="1800" b="0">
-                <a:solidFill>
-                  <a:srgbClr val="000000"/>
-                </a:solidFill>
-                <a:latin typeface="Times New Roman"/>
-              </a:defRPr>
-            </a:pPr>
-            <a:r>
-              <a:t>• Depressive Slump: Mouth corner downturn &amp; gaze depression</a:t>
-            </a:r>
-          </a:p>
-          <a:p>
-            <a:pPr>
-              <a:spcAft>
-                <a:spcPts val="800"/>
-              </a:spcAft>
-              <a:defRPr sz="1800" b="0">
-                <a:solidFill>
-                  <a:srgbClr val="000000"/>
-                </a:solidFill>
-                <a:latin typeface="Times New Roman"/>
-              </a:defRPr>
-            </a:pPr>
-            <a:r>
-              <a:t>• Anger/Frustration: Jaw clenching &amp; lip compression</a:t>
-            </a:r>
-          </a:p>
-          <a:p>
-            <a:pPr>
-              <a:spcAft>
-                <a:spcPts val="800"/>
-              </a:spcAft>
-              <a:defRPr sz="1800" b="0">
-                <a:solidFill>
-                  <a:srgbClr val="000000"/>
-                </a:solidFill>
-                <a:latin typeface="Times New Roman"/>
-              </a:defRPr>
-            </a:pPr>
-            <a:r>
-              <a:t>• Fear, Joy, and Neutral Calm</a:t>
-            </a:r>
-          </a:p>
-          <a:p>
-            <a:pPr>
-              <a:spcAft>
-                <a:spcPts val="800"/>
-              </a:spcAft>
-              <a:defRPr sz="1800" b="0">
-                <a:solidFill>
-                  <a:srgbClr val="000000"/>
-                </a:solidFill>
-                <a:latin typeface="Times New Roman"/>
-              </a:defRPr>
-            </a:pPr>
-          </a:p>
-          <a:p>
-            <a:pPr>
-              <a:spcAft>
-                <a:spcPts val="800"/>
-              </a:spcAft>
-              <a:defRPr sz="1800" b="0">
-                <a:solidFill>
-                  <a:srgbClr val="000000"/>
-                </a:solidFill>
-                <a:latin typeface="Times New Roman"/>
-              </a:defRPr>
-            </a:pPr>
-            <a:r>
-              <a:t>High-Tech Interface: Renders an enlarged 320x320px HD glass container featuring a glowing green tracking mesh reticle and real-time HUD confidence percentage badge.</a:t>
+              <a:t>2. ZEBRONICS Mic Acoustic Voice Prosody Engine:</a:t>
+            </a:r>
+          </a:p>
+          <a:p>
+            <a:pPr>
+              <a:spcAft>
+                <a:spcPts val="800"/>
+              </a:spcAft>
+              <a:defRPr sz="1800" b="0">
+                <a:solidFill>
+                  <a:srgbClr val="000000"/>
+                </a:solidFill>
+                <a:latin typeface="Times New Roman"/>
+              </a:defRPr>
+            </a:pPr>
+            <a:r>
+              <a:t>Librosa spectral pitch analysis measuring Fundamental Frequency (F0 pitch &gt;250Hz panic, &lt;120Hz depression) and speech pause duration (&gt;2.5s cognitive hesitation).</a:t>
+            </a:r>
+          </a:p>
+          <a:p>
+            <a:pPr>
+              <a:spcAft>
+                <a:spcPts val="800"/>
+              </a:spcAft>
+              <a:defRPr sz="1800" b="0">
+                <a:solidFill>
+                  <a:srgbClr val="000000"/>
+                </a:solidFill>
+                <a:latin typeface="Times New Roman"/>
+              </a:defRPr>
+            </a:pPr>
+          </a:p>
+          <a:p>
+            <a:pPr>
+              <a:spcAft>
+                <a:spcPts val="800"/>
+              </a:spcAft>
+              <a:defRPr sz="1900" b="1">
+                <a:solidFill>
+                  <a:srgbClr val="000000"/>
+                </a:solidFill>
+                <a:latin typeface="Times New Roman"/>
+              </a:defRPr>
+            </a:pPr>
+            <a:r>
+              <a:t>3. Live Widescreen Video Call Modal &amp; Continuous Voice Loop:</a:t>
+            </a:r>
+          </a:p>
+          <a:p>
+            <a:pPr>
+              <a:spcAft>
+                <a:spcPts val="800"/>
+              </a:spcAft>
+              <a:defRPr sz="1800" b="0">
+                <a:solidFill>
+                  <a:srgbClr val="000000"/>
+                </a:solidFill>
+                <a:latin typeface="Times New Roman"/>
+              </a:defRPr>
+            </a:pPr>
+            <a:r>
+              <a:t>Full Widescreen HD video window with real-time HUD overlay, live subtitles, and continuous hands-free voice loop (onend auto-listen) that automatically restarts mic listening upon response completion.</a:t>
             </a:r>
           </a:p>
         </p:txBody>
@@ -4473,7 +4441,7 @@
               </a:defRPr>
             </a:pPr>
             <a:r>
-              <a:t>ZEBRONICS MIC ACOUSTIC VOICE PROSODY ENGINE</a:t>
+              <a:t>DEDICATED EXPLAINABLE AI ENGINE (SHAP &amp; LIME)</a:t>
             </a:r>
           </a:p>
         </p:txBody>
@@ -4487,7 +4455,7 @@
         <p:spPr>
           <a:xfrm>
             <a:off x="731520" y="1371600"/>
-            <a:ext cx="10728655" cy="4937760"/>
+            <a:ext cx="5943600" cy="4937760"/>
           </a:xfrm>
           <a:prstGeom prst="rect">
             <a:avLst/>
@@ -4502,130 +4470,154 @@
           <a:p>
             <a:pPr>
               <a:spcAft>
-                <a:spcPts val="800"/>
-              </a:spcAft>
-              <a:defRPr sz="1900" b="1">
-                <a:solidFill>
-                  <a:srgbClr val="000000"/>
-                </a:solidFill>
-                <a:latin typeface="Times New Roman"/>
-              </a:defRPr>
-            </a:pPr>
-            <a:r>
-              <a:t>Librosa Spectral Pitch &amp; Pause Biomarker Processing:</a:t>
-            </a:r>
-          </a:p>
-          <a:p>
-            <a:pPr>
-              <a:spcAft>
-                <a:spcPts val="800"/>
-              </a:spcAft>
-              <a:defRPr sz="1800" b="0">
-                <a:solidFill>
-                  <a:srgbClr val="000000"/>
-                </a:solidFill>
-                <a:latin typeface="Times New Roman"/>
-              </a:defRPr>
-            </a:pPr>
-            <a:r>
-              <a:t>Captures high-fidelity speech audio via ZEBRONICS microphone and Web Speech API speech-to-text conversion.</a:t>
-            </a:r>
-          </a:p>
-          <a:p>
-            <a:pPr>
-              <a:spcAft>
-                <a:spcPts val="800"/>
-              </a:spcAft>
-              <a:defRPr sz="1800" b="0">
-                <a:solidFill>
-                  <a:srgbClr val="000000"/>
-                </a:solidFill>
-                <a:latin typeface="Times New Roman"/>
-              </a:defRPr>
-            </a:pPr>
-          </a:p>
-          <a:p>
-            <a:pPr>
-              <a:spcAft>
-                <a:spcPts val="800"/>
-              </a:spcAft>
-              <a:defRPr sz="1900" b="1">
-                <a:solidFill>
-                  <a:srgbClr val="000000"/>
-                </a:solidFill>
-                <a:latin typeface="Times New Roman"/>
-              </a:defRPr>
-            </a:pPr>
-            <a:r>
-              <a:t>Fundamental Frequency (F0 Pitch Delta):</a:t>
-            </a:r>
-          </a:p>
-          <a:p>
-            <a:pPr>
-              <a:spcAft>
-                <a:spcPts val="800"/>
-              </a:spcAft>
-              <a:defRPr sz="1800" b="0">
-                <a:solidFill>
-                  <a:srgbClr val="000000"/>
-                </a:solidFill>
-                <a:latin typeface="Times New Roman"/>
-              </a:defRPr>
-            </a:pPr>
-            <a:r>
-              <a:t>Librosa spectral analysis measuring pitch variance; high pitch (&gt;250Hz) indicates acute panic; monotone low pitch (&lt;120Hz) indicates depressive lethargy.</a:t>
-            </a:r>
-          </a:p>
-          <a:p>
-            <a:pPr>
-              <a:spcAft>
-                <a:spcPts val="800"/>
-              </a:spcAft>
-              <a:defRPr sz="1800" b="0">
-                <a:solidFill>
-                  <a:srgbClr val="000000"/>
-                </a:solidFill>
-                <a:latin typeface="Times New Roman"/>
-              </a:defRPr>
-            </a:pPr>
-          </a:p>
-          <a:p>
-            <a:pPr>
-              <a:spcAft>
-                <a:spcPts val="800"/>
-              </a:spcAft>
-              <a:defRPr sz="1900" b="1">
-                <a:solidFill>
-                  <a:srgbClr val="000000"/>
-                </a:solidFill>
-                <a:latin typeface="Times New Roman"/>
-              </a:defRPr>
-            </a:pPr>
-            <a:r>
-              <a:t>Speech Pause Duration:</a:t>
-            </a:r>
-          </a:p>
-          <a:p>
-            <a:pPr>
-              <a:spcAft>
-                <a:spcPts val="800"/>
-              </a:spcAft>
-              <a:defRPr sz="1800" b="0">
-                <a:solidFill>
-                  <a:srgbClr val="000000"/>
-                </a:solidFill>
-                <a:latin typeface="Times New Roman"/>
-              </a:defRPr>
-            </a:pPr>
-            <a:r>
-              <a:t>Measures speech hesitations longer than 2.5 seconds as indicators of cognitive overload, trauma processing, or emotional fatigue.</a:t>
-            </a:r>
-          </a:p>
-        </p:txBody>
-      </p:sp>
-      <p:sp>
-        <p:nvSpPr>
-          <p:cNvPr id="4" name="TextBox 3"/>
+                <a:spcPts val="600"/>
+              </a:spcAft>
+              <a:defRPr sz="1600" b="1">
+                <a:solidFill>
+                  <a:srgbClr val="000000"/>
+                </a:solidFill>
+                <a:latin typeface="Times New Roman"/>
+              </a:defRPr>
+            </a:pPr>
+            <a:r>
+              <a:t>Eliminating Black-Box AI Risks:</a:t>
+            </a:r>
+          </a:p>
+          <a:p>
+            <a:pPr>
+              <a:spcAft>
+                <a:spcPts val="600"/>
+              </a:spcAft>
+              <a:defRPr sz="1500" b="0">
+                <a:solidFill>
+                  <a:srgbClr val="000000"/>
+                </a:solidFill>
+                <a:latin typeface="Times New Roman"/>
+              </a:defRPr>
+            </a:pPr>
+            <a:r>
+              <a:t>Generates token attribution heatmaps, color-coding specific words in red (high-risk drivers) or green (calming influences).</a:t>
+            </a:r>
+          </a:p>
+          <a:p>
+            <a:pPr>
+              <a:spcAft>
+                <a:spcPts val="600"/>
+              </a:spcAft>
+              <a:defRPr sz="1500" b="0">
+                <a:solidFill>
+                  <a:srgbClr val="000000"/>
+                </a:solidFill>
+                <a:latin typeface="Times New Roman"/>
+              </a:defRPr>
+            </a:pPr>
+          </a:p>
+          <a:p>
+            <a:pPr>
+              <a:spcAft>
+                <a:spcPts val="600"/>
+              </a:spcAft>
+              <a:defRPr sz="1600" b="1">
+                <a:solidFill>
+                  <a:srgbClr val="000000"/>
+                </a:solidFill>
+                <a:latin typeface="Times New Roman"/>
+              </a:defRPr>
+            </a:pPr>
+            <a:r>
+              <a:t>SHAP &amp; LIME Attribution:</a:t>
+            </a:r>
+          </a:p>
+          <a:p>
+            <a:pPr>
+              <a:spcAft>
+                <a:spcPts val="600"/>
+              </a:spcAft>
+              <a:defRPr sz="1500" b="0">
+                <a:solidFill>
+                  <a:srgbClr val="000000"/>
+                </a:solidFill>
+                <a:latin typeface="Times New Roman"/>
+              </a:defRPr>
+            </a:pPr>
+            <a:r>
+              <a:t>• SHAP: Measures global feature importance across patient interaction history.</a:t>
+            </a:r>
+          </a:p>
+          <a:p>
+            <a:pPr>
+              <a:spcAft>
+                <a:spcPts val="600"/>
+              </a:spcAft>
+              <a:defRPr sz="1500" b="0">
+                <a:solidFill>
+                  <a:srgbClr val="000000"/>
+                </a:solidFill>
+                <a:latin typeface="Times New Roman"/>
+              </a:defRPr>
+            </a:pPr>
+            <a:r>
+              <a:t>• LIME: Explains specific high-risk predictions for individual patient messages.</a:t>
+            </a:r>
+          </a:p>
+          <a:p>
+            <a:pPr>
+              <a:spcAft>
+                <a:spcPts val="600"/>
+              </a:spcAft>
+              <a:defRPr sz="1500" b="0">
+                <a:solidFill>
+                  <a:srgbClr val="000000"/>
+                </a:solidFill>
+                <a:latin typeface="Times New Roman"/>
+              </a:defRPr>
+            </a:pPr>
+          </a:p>
+          <a:p>
+            <a:pPr>
+              <a:spcAft>
+                <a:spcPts val="600"/>
+              </a:spcAft>
+              <a:defRPr sz="1600" b="1">
+                <a:solidFill>
+                  <a:srgbClr val="000000"/>
+                </a:solidFill>
+                <a:latin typeface="Times New Roman"/>
+              </a:defRPr>
+            </a:pPr>
+            <a:r>
+              <a:t>Clinician Auditing: Empowers attending psychiatrists to verify mathematically why Keffi AI flagged a patient as High Risk (&lt;40 MHQ).</a:t>
+            </a:r>
+          </a:p>
+        </p:txBody>
+      </p:sp>
+      <p:pic>
+        <p:nvPicPr>
+          <p:cNvPr id="4" name="Picture 3" descr="keffi_3d_shap_lime_explainable_ai_1785782565856.png"/>
+          <p:cNvPicPr>
+            <a:picLocks noChangeAspect="1"/>
+          </p:cNvPicPr>
+          <p:nvPr/>
+        </p:nvPicPr>
+        <p:blipFill>
+          <a:blip r:embed="rId2"/>
+          <a:stretch>
+            <a:fillRect/>
+          </a:stretch>
+        </p:blipFill>
+        <p:spPr>
+          <a:xfrm>
+            <a:off x="6949440" y="1371600"/>
+            <a:ext cx="4480560" cy="4480560"/>
+          </a:xfrm>
+          <a:prstGeom prst="rect">
+            <a:avLst/>
+          </a:prstGeom>
+        </p:spPr>
+      </p:pic>
+      <p:sp>
+        <p:nvSpPr>
+          <p:cNvPr id="5" name="TextBox 4"/>
           <p:cNvSpPr txBox="1"/>
           <p:nvPr/>
         </p:nvSpPr>
@@ -4708,15 +4700,15 @@
           <a:lstStyle/>
           <a:p>
             <a:pPr>
-              <a:defRPr sz="2800" b="1">
-                <a:solidFill>
-                  <a:srgbClr val="000000"/>
-                </a:solidFill>
-                <a:latin typeface="Times New Roman"/>
-              </a:defRPr>
-            </a:pPr>
-            <a:r>
-              <a:t>LIVE VIDEO CALL &amp; HANDS-FREE VOICE AI</a:t>
+              <a:defRPr sz="2400" b="1">
+                <a:solidFill>
+                  <a:srgbClr val="000000"/>
+                </a:solidFill>
+                <a:latin typeface="Times New Roman"/>
+              </a:defRPr>
+            </a:pPr>
+            <a:r>
+              <a:t>LAYERED AI INFRASTRUCTURE &amp; BACKEND ARCHITECTURE</a:t>
             </a:r>
           </a:p>
         </p:txBody>
@@ -4730,7 +4722,7 @@
         <p:spPr>
           <a:xfrm>
             <a:off x="731520" y="1371600"/>
-            <a:ext cx="10728655" cy="4937760"/>
+            <a:ext cx="5943600" cy="4937760"/>
           </a:xfrm>
           <a:prstGeom prst="rect">
             <a:avLst/>
@@ -4745,114 +4737,112 @@
           <a:p>
             <a:pPr>
               <a:spcAft>
-                <a:spcPts val="800"/>
-              </a:spcAft>
-              <a:defRPr sz="1900" b="1">
-                <a:solidFill>
-                  <a:srgbClr val="000000"/>
-                </a:solidFill>
-                <a:latin typeface="Times New Roman"/>
-              </a:defRPr>
-            </a:pPr>
-            <a:r>
-              <a:t>Real-Time Widescreen Video Call UI Modal:</a:t>
-            </a:r>
-          </a:p>
-          <a:p>
-            <a:pPr>
-              <a:spcAft>
-                <a:spcPts val="800"/>
-              </a:spcAft>
-              <a:defRPr sz="1800" b="0">
-                <a:solidFill>
-                  <a:srgbClr val="000000"/>
-                </a:solidFill>
-                <a:latin typeface="Times New Roman"/>
-              </a:defRPr>
-            </a:pPr>
-            <a:r>
-              <a:t>Full Widescreen HD video window with real-time computer vision HUD overlay and live spoken subtitles.</a:t>
-            </a:r>
-          </a:p>
-          <a:p>
-            <a:pPr>
-              <a:spcAft>
-                <a:spcPts val="800"/>
-              </a:spcAft>
-              <a:defRPr sz="1800" b="0">
-                <a:solidFill>
-                  <a:srgbClr val="000000"/>
-                </a:solidFill>
-                <a:latin typeface="Times New Roman"/>
-              </a:defRPr>
-            </a:pPr>
-          </a:p>
-          <a:p>
-            <a:pPr>
-              <a:spcAft>
-                <a:spcPts val="800"/>
-              </a:spcAft>
-              <a:defRPr sz="1900" b="1">
-                <a:solidFill>
-                  <a:srgbClr val="000000"/>
-                </a:solidFill>
-                <a:latin typeface="Times New Roman"/>
-              </a:defRPr>
-            </a:pPr>
-            <a:r>
-              <a:t>Continuous Hands-Free Loop (onend auto-listen):</a:t>
-            </a:r>
-          </a:p>
-          <a:p>
-            <a:pPr>
-              <a:spcAft>
-                <a:spcPts val="800"/>
-              </a:spcAft>
-              <a:defRPr sz="1800" b="0">
-                <a:solidFill>
-                  <a:srgbClr val="000000"/>
-                </a:solidFill>
-                <a:latin typeface="Times New Roman"/>
-              </a:defRPr>
-            </a:pPr>
-            <a:r>
-              <a:t>Speech Synthesis automatically re-engages microphone listening upon response completion, allowing patients to converse continuously back and forth without pressing buttons.</a:t>
-            </a:r>
-          </a:p>
-          <a:p>
-            <a:pPr>
-              <a:spcAft>
-                <a:spcPts val="800"/>
-              </a:spcAft>
-              <a:defRPr sz="1800" b="0">
-                <a:solidFill>
-                  <a:srgbClr val="000000"/>
-                </a:solidFill>
-                <a:latin typeface="Times New Roman"/>
-              </a:defRPr>
-            </a:pPr>
-          </a:p>
-          <a:p>
-            <a:pPr>
-              <a:spcAft>
-                <a:spcPts val="800"/>
-              </a:spcAft>
-              <a:defRPr sz="1800" b="0">
-                <a:solidFill>
-                  <a:srgbClr val="000000"/>
-                </a:solidFill>
-                <a:latin typeface="Times New Roman"/>
-              </a:defRPr>
-            </a:pPr>
-            <a:r>
-              <a:t>Natural Voice Output: Speaks personalized 3-tier therapeutic replies in warm, natural vocal tones.</a:t>
-            </a:r>
-          </a:p>
-        </p:txBody>
-      </p:sp>
-      <p:sp>
-        <p:nvSpPr>
-          <p:cNvPr id="4" name="TextBox 3"/>
+                <a:spcPts val="600"/>
+              </a:spcAft>
+              <a:defRPr sz="1600" b="1">
+                <a:solidFill>
+                  <a:srgbClr val="000000"/>
+                </a:solidFill>
+                <a:latin typeface="Times New Roman"/>
+              </a:defRPr>
+            </a:pPr>
+            <a:r>
+              <a:t>4-Layered Cloud Architecture:</a:t>
+            </a:r>
+          </a:p>
+          <a:p>
+            <a:pPr>
+              <a:spcAft>
+                <a:spcPts val="600"/>
+              </a:spcAft>
+              <a:defRPr sz="1500" b="0">
+                <a:solidFill>
+                  <a:srgbClr val="000000"/>
+                </a:solidFill>
+                <a:latin typeface="Times New Roman"/>
+              </a:defRPr>
+            </a:pPr>
+            <a:r>
+              <a:t>1. Presentation Layer: React 18 + Vite frontend with TailwindCSS and glassmorphic UI tokens.</a:t>
+            </a:r>
+          </a:p>
+          <a:p>
+            <a:pPr>
+              <a:spcAft>
+                <a:spcPts val="600"/>
+              </a:spcAft>
+              <a:defRPr sz="1500" b="0">
+                <a:solidFill>
+                  <a:srgbClr val="000000"/>
+                </a:solidFill>
+                <a:latin typeface="Times New Roman"/>
+              </a:defRPr>
+            </a:pPr>
+            <a:r>
+              <a:t>2. API Gateway Layer: FastAPI REST server handling asynchronous CORS and routing.</a:t>
+            </a:r>
+          </a:p>
+          <a:p>
+            <a:pPr>
+              <a:spcAft>
+                <a:spcPts val="600"/>
+              </a:spcAft>
+              <a:defRPr sz="1500" b="0">
+                <a:solidFill>
+                  <a:srgbClr val="000000"/>
+                </a:solidFill>
+                <a:latin typeface="Times New Roman"/>
+              </a:defRPr>
+            </a:pPr>
+            <a:r>
+              <a:t>3. Cloud AI Brain: HuggingFace Cloud Space (Balajikrishnan031/Keffi-Backend) running PyTorch BERT transformer.</a:t>
+            </a:r>
+          </a:p>
+          <a:p>
+            <a:pPr>
+              <a:spcAft>
+                <a:spcPts val="600"/>
+              </a:spcAft>
+              <a:defRPr sz="1500" b="0">
+                <a:solidFill>
+                  <a:srgbClr val="000000"/>
+                </a:solidFill>
+                <a:latin typeface="Times New Roman"/>
+              </a:defRPr>
+            </a:pPr>
+            <a:r>
+              <a:t>4. Data Persistence Layer: High-concurrency Write-Ahead Logging (WAL) SQLite engine.</a:t>
+            </a:r>
+          </a:p>
+        </p:txBody>
+      </p:sp>
+      <p:pic>
+        <p:nvPicPr>
+          <p:cNvPr id="4" name="Picture 3" descr="keffi_3d_layered_system_architecture_1785782550460.png"/>
+          <p:cNvPicPr>
+            <a:picLocks noChangeAspect="1"/>
+          </p:cNvPicPr>
+          <p:nvPr/>
+        </p:nvPicPr>
+        <p:blipFill>
+          <a:blip r:embed="rId2"/>
+          <a:stretch>
+            <a:fillRect/>
+          </a:stretch>
+        </p:blipFill>
+        <p:spPr>
+          <a:xfrm>
+            <a:off x="6949440" y="1371600"/>
+            <a:ext cx="4480560" cy="4480560"/>
+          </a:xfrm>
+          <a:prstGeom prst="rect">
+            <a:avLst/>
+          </a:prstGeom>
+        </p:spPr>
+      </p:pic>
+      <p:sp>
+        <p:nvSpPr>
+          <p:cNvPr id="5" name="TextBox 4"/>
           <p:cNvSpPr txBox="1"/>
           <p:nvPr/>
         </p:nvSpPr>
@@ -4943,7 +4933,7 @@
               </a:defRPr>
             </a:pPr>
             <a:r>
-              <a:t>EXPLAINABLE AI ENGINE (SHAP &amp; LIME)</a:t>
+              <a:t>HYBRID PHQ-9 &amp; MHQ SCORING SYSTEM</a:t>
             </a:r>
           </a:p>
         </p:txBody>
@@ -4957,7 +4947,7 @@
         <p:spPr>
           <a:xfrm>
             <a:off x="731520" y="1371600"/>
-            <a:ext cx="5943600" cy="4937760"/>
+            <a:ext cx="10728655" cy="4937760"/>
           </a:xfrm>
           <a:prstGeom prst="rect">
             <a:avLst/>
@@ -4972,154 +4962,114 @@
           <a:p>
             <a:pPr>
               <a:spcAft>
-                <a:spcPts val="600"/>
-              </a:spcAft>
-              <a:defRPr sz="1600" b="1">
-                <a:solidFill>
-                  <a:srgbClr val="000000"/>
-                </a:solidFill>
-                <a:latin typeface="Times New Roman"/>
-              </a:defRPr>
-            </a:pPr>
-            <a:r>
-              <a:t>Eliminating Black-Box AI Risks:</a:t>
-            </a:r>
-          </a:p>
-          <a:p>
-            <a:pPr>
-              <a:spcAft>
-                <a:spcPts val="600"/>
-              </a:spcAft>
-              <a:defRPr sz="1500" b="0">
-                <a:solidFill>
-                  <a:srgbClr val="000000"/>
-                </a:solidFill>
-                <a:latin typeface="Times New Roman"/>
-              </a:defRPr>
-            </a:pPr>
-            <a:r>
-              <a:t>Generates token attribution heatmaps, color-coding specific words in red (high-risk drivers) or green (calming influences).</a:t>
-            </a:r>
-          </a:p>
-          <a:p>
-            <a:pPr>
-              <a:spcAft>
-                <a:spcPts val="600"/>
-              </a:spcAft>
-              <a:defRPr sz="1500" b="0">
-                <a:solidFill>
-                  <a:srgbClr val="000000"/>
-                </a:solidFill>
-                <a:latin typeface="Times New Roman"/>
-              </a:defRPr>
-            </a:pPr>
-          </a:p>
-          <a:p>
-            <a:pPr>
-              <a:spcAft>
-                <a:spcPts val="600"/>
-              </a:spcAft>
-              <a:defRPr sz="1600" b="1">
-                <a:solidFill>
-                  <a:srgbClr val="000000"/>
-                </a:solidFill>
-                <a:latin typeface="Times New Roman"/>
-              </a:defRPr>
-            </a:pPr>
-            <a:r>
-              <a:t>SHAP &amp; LIME Attribution:</a:t>
-            </a:r>
-          </a:p>
-          <a:p>
-            <a:pPr>
-              <a:spcAft>
-                <a:spcPts val="600"/>
-              </a:spcAft>
-              <a:defRPr sz="1500" b="0">
-                <a:solidFill>
-                  <a:srgbClr val="000000"/>
-                </a:solidFill>
-                <a:latin typeface="Times New Roman"/>
-              </a:defRPr>
-            </a:pPr>
-            <a:r>
-              <a:t>• SHAP: Measures global feature importance across patient interaction history.</a:t>
-            </a:r>
-          </a:p>
-          <a:p>
-            <a:pPr>
-              <a:spcAft>
-                <a:spcPts val="600"/>
-              </a:spcAft>
-              <a:defRPr sz="1500" b="0">
-                <a:solidFill>
-                  <a:srgbClr val="000000"/>
-                </a:solidFill>
-                <a:latin typeface="Times New Roman"/>
-              </a:defRPr>
-            </a:pPr>
-            <a:r>
-              <a:t>• LIME: Explains specific high-risk predictions for individual patient messages.</a:t>
-            </a:r>
-          </a:p>
-          <a:p>
-            <a:pPr>
-              <a:spcAft>
-                <a:spcPts val="600"/>
-              </a:spcAft>
-              <a:defRPr sz="1500" b="0">
-                <a:solidFill>
-                  <a:srgbClr val="000000"/>
-                </a:solidFill>
-                <a:latin typeface="Times New Roman"/>
-              </a:defRPr>
-            </a:pPr>
-          </a:p>
-          <a:p>
-            <a:pPr>
-              <a:spcAft>
-                <a:spcPts val="600"/>
-              </a:spcAft>
-              <a:defRPr sz="1600" b="1">
-                <a:solidFill>
-                  <a:srgbClr val="000000"/>
-                </a:solidFill>
-                <a:latin typeface="Times New Roman"/>
-              </a:defRPr>
-            </a:pPr>
-            <a:r>
-              <a:t>Clinician Auditing: Empowers attending psychiatrists to verify mathematically why Keffi AI flagged a patient as High Risk (&lt;40 MHQ).</a:t>
-            </a:r>
-          </a:p>
-        </p:txBody>
-      </p:sp>
-      <p:pic>
-        <p:nvPicPr>
-          <p:cNvPr id="4" name="Picture 3" descr="keffi_3d_shap_lime_explainable_ai_1785782565856.png"/>
-          <p:cNvPicPr>
-            <a:picLocks noChangeAspect="1"/>
-          </p:cNvPicPr>
-          <p:nvPr/>
-        </p:nvPicPr>
-        <p:blipFill>
-          <a:blip r:embed="rId2"/>
-          <a:stretch>
-            <a:fillRect/>
-          </a:stretch>
-        </p:blipFill>
-        <p:spPr>
-          <a:xfrm>
-            <a:off x="6949440" y="1371600"/>
-            <a:ext cx="4480560" cy="4480560"/>
-          </a:xfrm>
-          <a:prstGeom prst="rect">
-            <a:avLst/>
-          </a:prstGeom>
-        </p:spPr>
-      </p:pic>
-      <p:sp>
-        <p:nvSpPr>
-          <p:cNvPr id="5" name="TextBox 4"/>
+                <a:spcPts val="800"/>
+              </a:spcAft>
+              <a:defRPr sz="1900" b="1">
+                <a:solidFill>
+                  <a:srgbClr val="000000"/>
+                </a:solidFill>
+                <a:latin typeface="Times New Roman"/>
+              </a:defRPr>
+            </a:pPr>
+            <a:r>
+              <a:t>Quantitative Wellness Metrics:</a:t>
+            </a:r>
+          </a:p>
+          <a:p>
+            <a:pPr>
+              <a:spcAft>
+                <a:spcPts val="800"/>
+              </a:spcAft>
+              <a:defRPr sz="1800" b="0">
+                <a:solidFill>
+                  <a:srgbClr val="000000"/>
+                </a:solidFill>
+                <a:latin typeface="Times New Roman"/>
+              </a:defRPr>
+            </a:pPr>
+            <a:r>
+              <a:t>Mental Health Quotient (MHQ) dynamic 0-100 wellness score integrated with automated DSM-5 PHQ-9 depression evaluations.</a:t>
+            </a:r>
+          </a:p>
+          <a:p>
+            <a:pPr>
+              <a:spcAft>
+                <a:spcPts val="800"/>
+              </a:spcAft>
+              <a:defRPr sz="1800" b="0">
+                <a:solidFill>
+                  <a:srgbClr val="000000"/>
+                </a:solidFill>
+                <a:latin typeface="Times New Roman"/>
+              </a:defRPr>
+            </a:pPr>
+          </a:p>
+          <a:p>
+            <a:pPr>
+              <a:spcAft>
+                <a:spcPts val="800"/>
+              </a:spcAft>
+              <a:defRPr sz="1900" b="1">
+                <a:solidFill>
+                  <a:srgbClr val="000000"/>
+                </a:solidFill>
+                <a:latin typeface="Times New Roman"/>
+              </a:defRPr>
+            </a:pPr>
+            <a:r>
+              <a:t>9 Clinical Criteria Evaluated:</a:t>
+            </a:r>
+          </a:p>
+          <a:p>
+            <a:pPr>
+              <a:spcAft>
+                <a:spcPts val="800"/>
+              </a:spcAft>
+              <a:defRPr sz="1800" b="0">
+                <a:solidFill>
+                  <a:srgbClr val="000000"/>
+                </a:solidFill>
+                <a:latin typeface="Times New Roman"/>
+              </a:defRPr>
+            </a:pPr>
+            <a:r>
+              <a:t>Depressed mood, anhedonia, sleep disturbance, fatigue, appetite changes, worthlessness, concentration difficulty, agitation, self-harm ideation.</a:t>
+            </a:r>
+          </a:p>
+          <a:p>
+            <a:pPr>
+              <a:spcAft>
+                <a:spcPts val="800"/>
+              </a:spcAft>
+              <a:defRPr sz="1800" b="0">
+                <a:solidFill>
+                  <a:srgbClr val="000000"/>
+                </a:solidFill>
+                <a:latin typeface="Times New Roman"/>
+              </a:defRPr>
+            </a:pPr>
+          </a:p>
+          <a:p>
+            <a:pPr>
+              <a:spcAft>
+                <a:spcPts val="800"/>
+              </a:spcAft>
+              <a:defRPr sz="1800" b="0">
+                <a:solidFill>
+                  <a:srgbClr val="000000"/>
+                </a:solidFill>
+                <a:latin typeface="Times New Roman"/>
+              </a:defRPr>
+            </a:pPr>
+            <a:r>
+              <a:t>Risk Stratification Tiers: High Risk (&lt;40 MHQ), Moderate Risk (40-70 MHQ), Low Risk (&gt;70 MHQ). Tracks score deltas across time to alert supervisors to emotional drops.</a:t>
+            </a:r>
+          </a:p>
+        </p:txBody>
+      </p:sp>
+      <p:sp>
+        <p:nvSpPr>
+          <p:cNvPr id="4" name="TextBox 3"/>
           <p:cNvSpPr txBox="1"/>
           <p:nvPr/>
         </p:nvSpPr>
@@ -5202,15 +5152,15 @@
           <a:lstStyle/>
           <a:p>
             <a:pPr>
-              <a:defRPr sz="2400" b="1">
-                <a:solidFill>
-                  <a:srgbClr val="000000"/>
-                </a:solidFill>
-                <a:latin typeface="Times New Roman"/>
-              </a:defRPr>
-            </a:pPr>
-            <a:r>
-              <a:t>LAYERED AI INFRASTRUCTURE &amp; BACKEND ARCHITECTURE</a:t>
+              <a:defRPr sz="2800" b="1">
+                <a:solidFill>
+                  <a:srgbClr val="000000"/>
+                </a:solidFill>
+                <a:latin typeface="Times New Roman"/>
+              </a:defRPr>
+            </a:pPr>
+            <a:r>
+              <a:t>N8N CLINICAL AUTOMATION ENGINE</a:t>
             </a:r>
           </a:p>
         </p:txBody>
@@ -5224,7 +5174,7 @@
         <p:spPr>
           <a:xfrm>
             <a:off x="731520" y="1371600"/>
-            <a:ext cx="5943600" cy="4937760"/>
+            <a:ext cx="10728655" cy="4937760"/>
           </a:xfrm>
           <a:prstGeom prst="rect">
             <a:avLst/>
@@ -5239,112 +5189,114 @@
           <a:p>
             <a:pPr>
               <a:spcAft>
-                <a:spcPts val="600"/>
-              </a:spcAft>
-              <a:defRPr sz="1600" b="1">
-                <a:solidFill>
-                  <a:srgbClr val="000000"/>
-                </a:solidFill>
-                <a:latin typeface="Times New Roman"/>
-              </a:defRPr>
-            </a:pPr>
-            <a:r>
-              <a:t>4-Layered Cloud Architecture:</a:t>
-            </a:r>
-          </a:p>
-          <a:p>
-            <a:pPr>
-              <a:spcAft>
-                <a:spcPts val="600"/>
-              </a:spcAft>
-              <a:defRPr sz="1500" b="0">
-                <a:solidFill>
-                  <a:srgbClr val="000000"/>
-                </a:solidFill>
-                <a:latin typeface="Times New Roman"/>
-              </a:defRPr>
-            </a:pPr>
-            <a:r>
-              <a:t>1. Presentation Layer: React 18 + Vite frontend with TailwindCSS and glassmorphic UI tokens.</a:t>
-            </a:r>
-          </a:p>
-          <a:p>
-            <a:pPr>
-              <a:spcAft>
-                <a:spcPts val="600"/>
-              </a:spcAft>
-              <a:defRPr sz="1500" b="0">
-                <a:solidFill>
-                  <a:srgbClr val="000000"/>
-                </a:solidFill>
-                <a:latin typeface="Times New Roman"/>
-              </a:defRPr>
-            </a:pPr>
-            <a:r>
-              <a:t>2. API Gateway Layer: FastAPI REST server handling asynchronous CORS and routing.</a:t>
-            </a:r>
-          </a:p>
-          <a:p>
-            <a:pPr>
-              <a:spcAft>
-                <a:spcPts val="600"/>
-              </a:spcAft>
-              <a:defRPr sz="1500" b="0">
-                <a:solidFill>
-                  <a:srgbClr val="000000"/>
-                </a:solidFill>
-                <a:latin typeface="Times New Roman"/>
-              </a:defRPr>
-            </a:pPr>
-            <a:r>
-              <a:t>3. Cloud AI Brain: HuggingFace Cloud Space (Balajikrishnan031/Keffi-Backend) running PyTorch BERT transformer.</a:t>
-            </a:r>
-          </a:p>
-          <a:p>
-            <a:pPr>
-              <a:spcAft>
-                <a:spcPts val="600"/>
-              </a:spcAft>
-              <a:defRPr sz="1500" b="0">
-                <a:solidFill>
-                  <a:srgbClr val="000000"/>
-                </a:solidFill>
-                <a:latin typeface="Times New Roman"/>
-              </a:defRPr>
-            </a:pPr>
-            <a:r>
-              <a:t>4. Data Persistence Layer: High-concurrency Write-Ahead Logging (WAL) SQLite engine.</a:t>
-            </a:r>
-          </a:p>
-        </p:txBody>
-      </p:sp>
-      <p:pic>
-        <p:nvPicPr>
-          <p:cNvPr id="4" name="Picture 3" descr="keffi_3d_layered_system_architecture_1785782550460.png"/>
-          <p:cNvPicPr>
-            <a:picLocks noChangeAspect="1"/>
-          </p:cNvPicPr>
-          <p:nvPr/>
-        </p:nvPicPr>
-        <p:blipFill>
-          <a:blip r:embed="rId2"/>
-          <a:stretch>
-            <a:fillRect/>
-          </a:stretch>
-        </p:blipFill>
-        <p:spPr>
-          <a:xfrm>
-            <a:off x="6949440" y="1371600"/>
-            <a:ext cx="4480560" cy="4480560"/>
-          </a:xfrm>
-          <a:prstGeom prst="rect">
-            <a:avLst/>
-          </a:prstGeom>
-        </p:spPr>
-      </p:pic>
-      <p:sp>
-        <p:nvSpPr>
-          <p:cNvPr id="5" name="TextBox 4"/>
+                <a:spcPts val="800"/>
+              </a:spcAft>
+              <a:defRPr sz="1900" b="1">
+                <a:solidFill>
+                  <a:srgbClr val="000000"/>
+                </a:solidFill>
+                <a:latin typeface="Times New Roman"/>
+              </a:defRPr>
+            </a:pPr>
+            <a:r>
+              <a:t>Automated Crisis Protocol &amp; Multi-Channel Webhooks:</a:t>
+            </a:r>
+          </a:p>
+          <a:p>
+            <a:pPr>
+              <a:spcAft>
+                <a:spcPts val="800"/>
+              </a:spcAft>
+              <a:defRPr sz="1800" b="0">
+                <a:solidFill>
+                  <a:srgbClr val="000000"/>
+                </a:solidFill>
+                <a:latin typeface="Times New Roman"/>
+              </a:defRPr>
+            </a:pPr>
+            <a:r>
+              <a:t>When the BERT model or C-SSRS triage protocol detects self-harm keywords or severe panic surges (&lt;40 MHQ), the system bypasses standard chat and executes a safety-critical crisis branch.</a:t>
+            </a:r>
+          </a:p>
+          <a:p>
+            <a:pPr>
+              <a:spcAft>
+                <a:spcPts val="800"/>
+              </a:spcAft>
+              <a:defRPr sz="1800" b="0">
+                <a:solidFill>
+                  <a:srgbClr val="000000"/>
+                </a:solidFill>
+                <a:latin typeface="Times New Roman"/>
+              </a:defRPr>
+            </a:pPr>
+          </a:p>
+          <a:p>
+            <a:pPr>
+              <a:spcAft>
+                <a:spcPts val="800"/>
+              </a:spcAft>
+              <a:defRPr sz="1900" b="1">
+                <a:solidFill>
+                  <a:srgbClr val="000000"/>
+                </a:solidFill>
+                <a:latin typeface="Times New Roman"/>
+              </a:defRPr>
+            </a:pPr>
+            <a:r>
+              <a:t>Multi-Channel Dispatches:</a:t>
+            </a:r>
+          </a:p>
+          <a:p>
+            <a:pPr>
+              <a:spcAft>
+                <a:spcPts val="800"/>
+              </a:spcAft>
+              <a:defRPr sz="1800" b="0">
+                <a:solidFill>
+                  <a:srgbClr val="000000"/>
+                </a:solidFill>
+                <a:latin typeface="Times New Roman"/>
+              </a:defRPr>
+            </a:pPr>
+            <a:r>
+              <a:t>The n8n workflow engine dispatches real-time webhooks, triggering instant WhatsApp messages and SMS alerts to designated family caregivers and attending psychiatrists.</a:t>
+            </a:r>
+          </a:p>
+          <a:p>
+            <a:pPr>
+              <a:spcAft>
+                <a:spcPts val="800"/>
+              </a:spcAft>
+              <a:defRPr sz="1800" b="0">
+                <a:solidFill>
+                  <a:srgbClr val="000000"/>
+                </a:solidFill>
+                <a:latin typeface="Times New Roman"/>
+              </a:defRPr>
+            </a:pPr>
+          </a:p>
+          <a:p>
+            <a:pPr>
+              <a:spcAft>
+                <a:spcPts val="800"/>
+              </a:spcAft>
+              <a:defRPr sz="1900" b="1">
+                <a:solidFill>
+                  <a:srgbClr val="000000"/>
+                </a:solidFill>
+                <a:latin typeface="Times New Roman"/>
+              </a:defRPr>
+            </a:pPr>
+            <a:r>
+              <a:t>Zero-Latency Escalation: Eliminates manual reporting delays during life-threatening emotional crises.</a:t>
+            </a:r>
+          </a:p>
+        </p:txBody>
+      </p:sp>
+      <p:sp>
+        <p:nvSpPr>
+          <p:cNvPr id="4" name="TextBox 3"/>
           <p:cNvSpPr txBox="1"/>
           <p:nvPr/>
         </p:nvSpPr>
@@ -5435,7 +5387,7 @@
               </a:defRPr>
             </a:pPr>
             <a:r>
-              <a:t>N8N CLINICAL AUTOMATION ENGINE</a:t>
+              <a:t>EXECUTIVE ADMIN CLINICAL HUB</a:t>
             </a:r>
           </a:p>
         </p:txBody>
@@ -5474,23 +5426,23 @@
               </a:defRPr>
             </a:pPr>
             <a:r>
-              <a:t>Automated Crisis Protocol &amp; Multi-Channel Webhooks:</a:t>
-            </a:r>
-          </a:p>
-          <a:p>
-            <a:pPr>
-              <a:spcAft>
-                <a:spcPts val="800"/>
-              </a:spcAft>
-              <a:defRPr sz="1800" b="0">
-                <a:solidFill>
-                  <a:srgbClr val="000000"/>
-                </a:solidFill>
-                <a:latin typeface="Times New Roman"/>
-              </a:defRPr>
-            </a:pPr>
-            <a:r>
-              <a:t>When the BERT model or C-SSRS triage protocol detects self-harm keywords or severe panic surges (&lt;40 MHQ), the system bypasses standard chat and executes a safety-critical crisis branch.</a:t>
+              <a:t>Centralized Outpatient Supervision Dashboard:</a:t>
+            </a:r>
+          </a:p>
+          <a:p>
+            <a:pPr>
+              <a:spcAft>
+                <a:spcPts val="800"/>
+              </a:spcAft>
+              <a:defRPr sz="1800" b="0">
+                <a:solidFill>
+                  <a:srgbClr val="000000"/>
+                </a:solidFill>
+                <a:latin typeface="Times New Roman"/>
+              </a:defRPr>
+            </a:pPr>
+            <a:r>
+              <a:t>Formatted in clean corporate dark teal typography (#2C5555), removing cluttered script fonts for medical clarity.</a:t>
             </a:r>
           </a:p>
           <a:p>
@@ -5519,52 +5471,52 @@
               </a:defRPr>
             </a:pPr>
             <a:r>
-              <a:t>Multi-Channel Dispatches:</a:t>
-            </a:r>
-          </a:p>
-          <a:p>
-            <a:pPr>
-              <a:spcAft>
-                <a:spcPts val="800"/>
-              </a:spcAft>
-              <a:defRPr sz="1800" b="0">
-                <a:solidFill>
-                  <a:srgbClr val="000000"/>
-                </a:solidFill>
-                <a:latin typeface="Times New Roman"/>
-              </a:defRPr>
-            </a:pPr>
-            <a:r>
-              <a:t>The n8n workflow engine dispatches real-time webhooks, triggering instant WhatsApp messages and SMS alerts to designated family caregivers and attending psychiatrists.</a:t>
-            </a:r>
-          </a:p>
-          <a:p>
-            <a:pPr>
-              <a:spcAft>
-                <a:spcPts val="800"/>
-              </a:spcAft>
-              <a:defRPr sz="1800" b="0">
-                <a:solidFill>
-                  <a:srgbClr val="000000"/>
-                </a:solidFill>
-                <a:latin typeface="Times New Roman"/>
-              </a:defRPr>
-            </a:pPr>
-          </a:p>
-          <a:p>
-            <a:pPr>
-              <a:spcAft>
-                <a:spcPts val="800"/>
-              </a:spcAft>
-              <a:defRPr sz="1900" b="1">
-                <a:solidFill>
-                  <a:srgbClr val="000000"/>
-                </a:solidFill>
-                <a:latin typeface="Times New Roman"/>
-              </a:defRPr>
-            </a:pPr>
-            <a:r>
-              <a:t>Zero-Latency Escalation: Eliminates manual reporting delays during life-threatening emotional crises.</a:t>
+              <a:t>Risk Category Filtering:</a:t>
+            </a:r>
+          </a:p>
+          <a:p>
+            <a:pPr>
+              <a:spcAft>
+                <a:spcPts val="800"/>
+              </a:spcAft>
+              <a:defRPr sz="1800" b="0">
+                <a:solidFill>
+                  <a:srgbClr val="000000"/>
+                </a:solidFill>
+                <a:latin typeface="Times New Roman"/>
+              </a:defRPr>
+            </a:pPr>
+            <a:r>
+              <a:t>Supervisors can filter patient rosters across High Risk (&lt;40 MHQ), Moderate Risk (40-70 MHQ), and Low Risk (&gt;70 MHQ) tiers instantly.</a:t>
+            </a:r>
+          </a:p>
+          <a:p>
+            <a:pPr>
+              <a:spcAft>
+                <a:spcPts val="800"/>
+              </a:spcAft>
+              <a:defRPr sz="1800" b="0">
+                <a:solidFill>
+                  <a:srgbClr val="000000"/>
+                </a:solidFill>
+                <a:latin typeface="Times New Roman"/>
+              </a:defRPr>
+            </a:pPr>
+          </a:p>
+          <a:p>
+            <a:pPr>
+              <a:spcAft>
+                <a:spcPts val="800"/>
+              </a:spcAft>
+              <a:defRPr sz="1800" b="0">
+                <a:solidFill>
+                  <a:srgbClr val="000000"/>
+                </a:solidFill>
+                <a:latin typeface="Times New Roman"/>
+              </a:defRPr>
+            </a:pPr>
+            <a:r>
+              <a:t>Complete Transcripts: Displays complete historical conversation transcripts with timestamped BERT emotion tags, SHAP heatmaps, and Librosa prosody metrics.</a:t>
             </a:r>
           </a:p>
         </p:txBody>
@@ -5662,7 +5614,7 @@
               </a:defRPr>
             </a:pPr>
             <a:r>
-              <a:t>EXECUTIVE ADMIN CLINICAL HUB</a:t>
+              <a:t>AUTOMATED DOCTOR APPOINTMENT BOOKING</a:t>
             </a:r>
           </a:p>
         </p:txBody>
@@ -5701,23 +5653,23 @@
               </a:defRPr>
             </a:pPr>
             <a:r>
-              <a:t>Centralized Outpatient Supervision Dashboard:</a:t>
-            </a:r>
-          </a:p>
-          <a:p>
-            <a:pPr>
-              <a:spcAft>
-                <a:spcPts val="800"/>
-              </a:spcAft>
-              <a:defRPr sz="1800" b="0">
-                <a:solidFill>
-                  <a:srgbClr val="000000"/>
-                </a:solidFill>
-                <a:latin typeface="Times New Roman"/>
-              </a:defRPr>
-            </a:pPr>
-            <a:r>
-              <a:t>Formatted in clean corporate dark teal typography (#2C5555), removing cluttered script fonts for medical clarity.</a:t>
+              <a:t>Seamless Clinical Intervention for High-Risk Patients:</a:t>
+            </a:r>
+          </a:p>
+          <a:p>
+            <a:pPr>
+              <a:spcAft>
+                <a:spcPts val="800"/>
+              </a:spcAft>
+              <a:defRPr sz="1800" b="0">
+                <a:solidFill>
+                  <a:srgbClr val="000000"/>
+                </a:solidFill>
+                <a:latin typeface="Times New Roman"/>
+              </a:defRPr>
+            </a:pPr>
+            <a:r>
+              <a:t>Direct scheduling with lead psychiatrists (Dr. S. Sivanesh M.Tech., Ph.D. or Dr. S. Rajesh M.D. Psychiatry).</a:t>
             </a:r>
           </a:p>
           <a:p>
@@ -5746,52 +5698,52 @@
               </a:defRPr>
             </a:pPr>
             <a:r>
-              <a:t>Risk Category Filtering:</a:t>
-            </a:r>
-          </a:p>
-          <a:p>
-            <a:pPr>
-              <a:spcAft>
-                <a:spcPts val="800"/>
-              </a:spcAft>
-              <a:defRPr sz="1800" b="0">
-                <a:solidFill>
-                  <a:srgbClr val="000000"/>
-                </a:solidFill>
-                <a:latin typeface="Times New Roman"/>
-              </a:defRPr>
-            </a:pPr>
-            <a:r>
-              <a:t>Supervisors can filter patient rosters across High Risk (&lt;40 MHQ), Moderate Risk (40-70 MHQ), and Low Risk (&gt;70 MHQ) tiers instantly.</a:t>
-            </a:r>
-          </a:p>
-          <a:p>
-            <a:pPr>
-              <a:spcAft>
-                <a:spcPts val="800"/>
-              </a:spcAft>
-              <a:defRPr sz="1800" b="0">
-                <a:solidFill>
-                  <a:srgbClr val="000000"/>
-                </a:solidFill>
-                <a:latin typeface="Times New Roman"/>
-              </a:defRPr>
-            </a:pPr>
-          </a:p>
-          <a:p>
-            <a:pPr>
-              <a:spcAft>
-                <a:spcPts val="800"/>
-              </a:spcAft>
-              <a:defRPr sz="1800" b="0">
-                <a:solidFill>
-                  <a:srgbClr val="000000"/>
-                </a:solidFill>
-                <a:latin typeface="Times New Roman"/>
-              </a:defRPr>
-            </a:pPr>
-            <a:r>
-              <a:t>Complete Transcripts: Displays complete historical conversation transcripts with timestamped BERT emotion tags, SHAP heatmaps, and Librosa prosody metrics.</a:t>
+              <a:t>One-Click Auto-Booking:</a:t>
+            </a:r>
+          </a:p>
+          <a:p>
+            <a:pPr>
+              <a:spcAft>
+                <a:spcPts val="800"/>
+              </a:spcAft>
+              <a:defRPr sz="1800" b="0">
+                <a:solidFill>
+                  <a:srgbClr val="000000"/>
+                </a:solidFill>
+                <a:latin typeface="Times New Roman"/>
+              </a:defRPr>
+            </a:pPr>
+            <a:r>
+              <a:t>Clinical supervisors can trigger automated appointment booking directly from the Admin Hub with 1 click.</a:t>
+            </a:r>
+          </a:p>
+          <a:p>
+            <a:pPr>
+              <a:spcAft>
+                <a:spcPts val="800"/>
+              </a:spcAft>
+              <a:defRPr sz="1800" b="0">
+                <a:solidFill>
+                  <a:srgbClr val="000000"/>
+                </a:solidFill>
+                <a:latin typeface="Times New Roman"/>
+              </a:defRPr>
+            </a:pPr>
+          </a:p>
+          <a:p>
+            <a:pPr>
+              <a:spcAft>
+                <a:spcPts val="800"/>
+              </a:spcAft>
+              <a:defRPr sz="1800" b="0">
+                <a:solidFill>
+                  <a:srgbClr val="000000"/>
+                </a:solidFill>
+                <a:latin typeface="Times New Roman"/>
+              </a:defRPr>
+            </a:pPr>
+            <a:r>
+              <a:t>Slot Reservation &amp; Confirmation: Reserves date/time slots in SQLite database and dispatches automated WhatsApp confirmation toasts.</a:t>
             </a:r>
           </a:p>
         </p:txBody>
@@ -5889,7 +5841,7 @@
               </a:defRPr>
             </a:pPr>
             <a:r>
-              <a:t>ABSTRACT</a:t>
+              <a:t>EXECUTIVE SUMMARY &amp; CLINICAL ABSTRACT</a:t>
             </a:r>
           </a:p>
         </p:txBody>
@@ -6113,7 +6065,7 @@
               </a:defRPr>
             </a:pPr>
             <a:r>
-              <a:t>AUTOMATED DOCTOR APPOINTMENT BOOKING</a:t>
+              <a:t>ATTRITION &amp; LOSS OF FOLLOW-UP ANALYTICS</a:t>
             </a:r>
           </a:p>
         </p:txBody>
@@ -6152,23 +6104,23 @@
               </a:defRPr>
             </a:pPr>
             <a:r>
-              <a:t>Seamless Clinical Intervention for High-Risk Patients:</a:t>
-            </a:r>
-          </a:p>
-          <a:p>
-            <a:pPr>
-              <a:spcAft>
-                <a:spcPts val="800"/>
-              </a:spcAft>
-              <a:defRPr sz="1800" b="0">
-                <a:solidFill>
-                  <a:srgbClr val="000000"/>
-                </a:solidFill>
-                <a:latin typeface="Times New Roman"/>
-              </a:defRPr>
-            </a:pPr>
-            <a:r>
-              <a:t>Direct scheduling with lead psychiatrists (Dr. S. Sivanesh M.Tech., Ph.D. or Dr. S. Rajesh M.D. Psychiatry).</a:t>
+              <a:t>20 Attrition Categories:</a:t>
+            </a:r>
+          </a:p>
+          <a:p>
+            <a:pPr>
+              <a:spcAft>
+                <a:spcPts val="800"/>
+              </a:spcAft>
+              <a:defRPr sz="1800" b="0">
+                <a:solidFill>
+                  <a:srgbClr val="000000"/>
+                </a:solidFill>
+                <a:latin typeface="Times New Roman"/>
+              </a:defRPr>
+            </a:pPr>
+            <a:r>
+              <a:t>Tracks voluntary dropout, stigma-induced exit, non-compliance, perceived recovery, and demographic transition.</a:t>
             </a:r>
           </a:p>
           <a:p>
@@ -6197,52 +6149,52 @@
               </a:defRPr>
             </a:pPr>
             <a:r>
-              <a:t>One-Click Auto-Booking:</a:t>
-            </a:r>
-          </a:p>
-          <a:p>
-            <a:pPr>
-              <a:spcAft>
-                <a:spcPts val="800"/>
-              </a:spcAft>
-              <a:defRPr sz="1800" b="0">
-                <a:solidFill>
-                  <a:srgbClr val="000000"/>
-                </a:solidFill>
-                <a:latin typeface="Times New Roman"/>
-              </a:defRPr>
-            </a:pPr>
-            <a:r>
-              <a:t>Clinical supervisors can trigger automated appointment booking directly from the Admin Hub with 1 click.</a:t>
-            </a:r>
-          </a:p>
-          <a:p>
-            <a:pPr>
-              <a:spcAft>
-                <a:spcPts val="800"/>
-              </a:spcAft>
-              <a:defRPr sz="1800" b="0">
-                <a:solidFill>
-                  <a:srgbClr val="000000"/>
-                </a:solidFill>
-                <a:latin typeface="Times New Roman"/>
-              </a:defRPr>
-            </a:pPr>
-          </a:p>
-          <a:p>
-            <a:pPr>
-              <a:spcAft>
-                <a:spcPts val="800"/>
-              </a:spcAft>
-              <a:defRPr sz="1800" b="0">
-                <a:solidFill>
-                  <a:srgbClr val="000000"/>
-                </a:solidFill>
-                <a:latin typeface="Times New Roman"/>
-              </a:defRPr>
-            </a:pPr>
-            <a:r>
-              <a:t>Slot Reservation &amp; Confirmation: Reserves date/time slots in SQLite database and dispatches automated WhatsApp confirmation toasts.</a:t>
+              <a:t>17 Loss of Follow-up Types:</a:t>
+            </a:r>
+          </a:p>
+          <a:p>
+            <a:pPr>
+              <a:spcAft>
+                <a:spcPts val="800"/>
+              </a:spcAft>
+              <a:defRPr sz="1800" b="0">
+                <a:solidFill>
+                  <a:srgbClr val="000000"/>
+                </a:solidFill>
+                <a:latin typeface="Times New Roman"/>
+              </a:defRPr>
+            </a:pPr>
+            <a:r>
+              <a:t>Classifies silent contact loss, passive dropout, geographic relocation, morbidity, and administrative system loss.</a:t>
+            </a:r>
+          </a:p>
+          <a:p>
+            <a:pPr>
+              <a:spcAft>
+                <a:spcPts val="800"/>
+              </a:spcAft>
+              <a:defRPr sz="1800" b="0">
+                <a:solidFill>
+                  <a:srgbClr val="000000"/>
+                </a:solidFill>
+                <a:latin typeface="Times New Roman"/>
+              </a:defRPr>
+            </a:pPr>
+          </a:p>
+          <a:p>
+            <a:pPr>
+              <a:spcAft>
+                <a:spcPts val="800"/>
+              </a:spcAft>
+              <a:defRPr sz="1800" b="0">
+                <a:solidFill>
+                  <a:srgbClr val="000000"/>
+                </a:solidFill>
+                <a:latin typeface="Times New Roman"/>
+              </a:defRPr>
+            </a:pPr>
+            <a:r>
+              <a:t>Proactive Re-engagement: Triggers automated n8n workflow check-ins when patients remain inactive for more than 48 hours.</a:t>
             </a:r>
           </a:p>
         </p:txBody>
@@ -6340,7 +6292,7 @@
               </a:defRPr>
             </a:pPr>
             <a:r>
-              <a:t>HYBRID PHQ-9 &amp; MHQ SCORING SYSTEM</a:t>
+              <a:t>SOMATIC &amp; GROUNDING CBT INTERVENTIONS</a:t>
             </a:r>
           </a:p>
         </p:txBody>
@@ -6379,23 +6331,23 @@
               </a:defRPr>
             </a:pPr>
             <a:r>
-              <a:t>Quantitative Wellness Metrics:</a:t>
-            </a:r>
-          </a:p>
-          <a:p>
-            <a:pPr>
-              <a:spcAft>
-                <a:spcPts val="800"/>
-              </a:spcAft>
-              <a:defRPr sz="1800" b="0">
-                <a:solidFill>
-                  <a:srgbClr val="000000"/>
-                </a:solidFill>
-                <a:latin typeface="Times New Roman"/>
-              </a:defRPr>
-            </a:pPr>
-            <a:r>
-              <a:t>Mental Health Quotient (MHQ) dynamic 0-100 wellness score integrated with automated DSM-5 PHQ-9 depression evaluations.</a:t>
+              <a:t>4-7-8 Somatic Breathing:</a:t>
+            </a:r>
+          </a:p>
+          <a:p>
+            <a:pPr>
+              <a:spcAft>
+                <a:spcPts val="800"/>
+              </a:spcAft>
+              <a:defRPr sz="1800" b="0">
+                <a:solidFill>
+                  <a:srgbClr val="000000"/>
+                </a:solidFill>
+                <a:latin typeface="Times New Roman"/>
+              </a:defRPr>
+            </a:pPr>
+            <a:r>
+              <a:t>Visual pacing guide (inhale 4s, hold 7s, exhale 8s) stimulating the parasympathetic vagus nerve to lower heart rate and calm panic.</a:t>
             </a:r>
           </a:p>
           <a:p>
@@ -6424,52 +6376,52 @@
               </a:defRPr>
             </a:pPr>
             <a:r>
-              <a:t>9 Clinical Criteria Evaluated:</a:t>
-            </a:r>
-          </a:p>
-          <a:p>
-            <a:pPr>
-              <a:spcAft>
-                <a:spcPts val="800"/>
-              </a:spcAft>
-              <a:defRPr sz="1800" b="0">
-                <a:solidFill>
-                  <a:srgbClr val="000000"/>
-                </a:solidFill>
-                <a:latin typeface="Times New Roman"/>
-              </a:defRPr>
-            </a:pPr>
-            <a:r>
-              <a:t>Depressed mood, anhedonia, sleep disturbance, fatigue, appetite changes, worthlessness, concentration difficulty, agitation, self-harm ideation.</a:t>
-            </a:r>
-          </a:p>
-          <a:p>
-            <a:pPr>
-              <a:spcAft>
-                <a:spcPts val="800"/>
-              </a:spcAft>
-              <a:defRPr sz="1800" b="0">
-                <a:solidFill>
-                  <a:srgbClr val="000000"/>
-                </a:solidFill>
-                <a:latin typeface="Times New Roman"/>
-              </a:defRPr>
-            </a:pPr>
-          </a:p>
-          <a:p>
-            <a:pPr>
-              <a:spcAft>
-                <a:spcPts val="800"/>
-              </a:spcAft>
-              <a:defRPr sz="1800" b="0">
-                <a:solidFill>
-                  <a:srgbClr val="000000"/>
-                </a:solidFill>
-                <a:latin typeface="Times New Roman"/>
-              </a:defRPr>
-            </a:pPr>
-            <a:r>
-              <a:t>Risk Stratification Tiers: High Risk (&lt;40 MHQ), Moderate Risk (40-70 MHQ), Low Risk (&gt;70 MHQ). Tracks score deltas across time to alert supervisors to emotional drops.</a:t>
+              <a:t>5-4-3-2-1 Sensory Grounding:</a:t>
+            </a:r>
+          </a:p>
+          <a:p>
+            <a:pPr>
+              <a:spcAft>
+                <a:spcPts val="800"/>
+              </a:spcAft>
+              <a:defRPr sz="1800" b="0">
+                <a:solidFill>
+                  <a:srgbClr val="000000"/>
+                </a:solidFill>
+                <a:latin typeface="Times New Roman"/>
+              </a:defRPr>
+            </a:pPr>
+            <a:r>
+              <a:t>Interactive exercise guiding patients to identify 5 sights, 4 touch sensations, 3 sounds, 2 smells, and 1 taste.</a:t>
+            </a:r>
+          </a:p>
+          <a:p>
+            <a:pPr>
+              <a:spcAft>
+                <a:spcPts val="800"/>
+              </a:spcAft>
+              <a:defRPr sz="1800" b="0">
+                <a:solidFill>
+                  <a:srgbClr val="000000"/>
+                </a:solidFill>
+                <a:latin typeface="Times New Roman"/>
+              </a:defRPr>
+            </a:pPr>
+          </a:p>
+          <a:p>
+            <a:pPr>
+              <a:spcAft>
+                <a:spcPts val="800"/>
+              </a:spcAft>
+              <a:defRPr sz="1800" b="0">
+                <a:solidFill>
+                  <a:srgbClr val="000000"/>
+                </a:solidFill>
+                <a:latin typeface="Times New Roman"/>
+              </a:defRPr>
+            </a:pPr>
+            <a:r>
+              <a:t>Music Sanctuary: Integrated ambient soundscapes and binaural beats for acute anxiety reduction.</a:t>
             </a:r>
           </a:p>
         </p:txBody>
@@ -6567,7 +6519,7 @@
               </a:defRPr>
             </a:pPr>
             <a:r>
-              <a:t>ATTRITION &amp; LOSS OF FOLLOW-UP ANALYTICS</a:t>
+              <a:t>SYSTEM REQUIREMENTS &amp; DEPLOYMENT PARAMETERS</a:t>
             </a:r>
           </a:p>
         </p:txBody>
@@ -6606,97 +6558,55 @@
               </a:defRPr>
             </a:pPr>
             <a:r>
-              <a:t>20 Attrition Categories:</a:t>
-            </a:r>
-          </a:p>
-          <a:p>
-            <a:pPr>
-              <a:spcAft>
-                <a:spcPts val="800"/>
-              </a:spcAft>
-              <a:defRPr sz="1800" b="0">
-                <a:solidFill>
-                  <a:srgbClr val="000000"/>
-                </a:solidFill>
-                <a:latin typeface="Times New Roman"/>
-              </a:defRPr>
-            </a:pPr>
-            <a:r>
-              <a:t>Tracks voluntary dropout, stigma-induced exit, non-compliance, perceived recovery, and demographic transition.</a:t>
-            </a:r>
-          </a:p>
-          <a:p>
-            <a:pPr>
-              <a:spcAft>
-                <a:spcPts val="800"/>
-              </a:spcAft>
-              <a:defRPr sz="1800" b="0">
-                <a:solidFill>
-                  <a:srgbClr val="000000"/>
-                </a:solidFill>
-                <a:latin typeface="Times New Roman"/>
-              </a:defRPr>
-            </a:pPr>
-          </a:p>
-          <a:p>
-            <a:pPr>
-              <a:spcAft>
-                <a:spcPts val="800"/>
-              </a:spcAft>
-              <a:defRPr sz="1900" b="1">
-                <a:solidFill>
-                  <a:srgbClr val="000000"/>
-                </a:solidFill>
-                <a:latin typeface="Times New Roman"/>
-              </a:defRPr>
-            </a:pPr>
-            <a:r>
-              <a:t>17 Loss of Follow-up Types:</a:t>
-            </a:r>
-          </a:p>
-          <a:p>
-            <a:pPr>
-              <a:spcAft>
-                <a:spcPts val="800"/>
-              </a:spcAft>
-              <a:defRPr sz="1800" b="0">
-                <a:solidFill>
-                  <a:srgbClr val="000000"/>
-                </a:solidFill>
-                <a:latin typeface="Times New Roman"/>
-              </a:defRPr>
-            </a:pPr>
-            <a:r>
-              <a:t>Classifies silent contact loss, passive dropout, geographic relocation, morbidity, and administrative system loss.</a:t>
-            </a:r>
-          </a:p>
-          <a:p>
-            <a:pPr>
-              <a:spcAft>
-                <a:spcPts val="800"/>
-              </a:spcAft>
-              <a:defRPr sz="1800" b="0">
-                <a:solidFill>
-                  <a:srgbClr val="000000"/>
-                </a:solidFill>
-                <a:latin typeface="Times New Roman"/>
-              </a:defRPr>
-            </a:pPr>
-          </a:p>
-          <a:p>
-            <a:pPr>
-              <a:spcAft>
-                <a:spcPts val="800"/>
-              </a:spcAft>
-              <a:defRPr sz="1800" b="0">
-                <a:solidFill>
-                  <a:srgbClr val="000000"/>
-                </a:solidFill>
-                <a:latin typeface="Times New Roman"/>
-              </a:defRPr>
-            </a:pPr>
-            <a:r>
-              <a:t>Proactive Re-engagement: Triggers automated n8n workflow check-ins when patients remain inactive for more than 48 hours.</a:t>
+              <a:t>Hardware Requirements: FINGERS HD Webcam (720p/1080p), ZEBRONICS USB/3.5mm Microphone, 8GB+ RAM, Multi-core CPU.</a:t>
+            </a:r>
+          </a:p>
+          <a:p>
+            <a:pPr>
+              <a:spcAft>
+                <a:spcPts val="800"/>
+              </a:spcAft>
+              <a:defRPr sz="1800" b="0">
+                <a:solidFill>
+                  <a:srgbClr val="000000"/>
+                </a:solidFill>
+                <a:latin typeface="Times New Roman"/>
+              </a:defRPr>
+            </a:pPr>
+            <a:r>
+              <a:t>Client Environment: Modern Web Browser (Google Chrome / Edge) with Web Speech &amp; WebRTC support.</a:t>
+            </a:r>
+          </a:p>
+          <a:p>
+            <a:pPr>
+              <a:spcAft>
+                <a:spcPts val="800"/>
+              </a:spcAft>
+              <a:defRPr sz="1800" b="0">
+                <a:solidFill>
+                  <a:srgbClr val="000000"/>
+                </a:solidFill>
+                <a:latin typeface="Times New Roman"/>
+              </a:defRPr>
+            </a:pPr>
+            <a:r>
+              <a:t>Backend Stack: Python 3.12, FastAPI, PyTorch, Librosa, HuggingFace Hub, SQLite (WAL mode).</a:t>
+            </a:r>
+          </a:p>
+          <a:p>
+            <a:pPr>
+              <a:spcAft>
+                <a:spcPts val="800"/>
+              </a:spcAft>
+              <a:defRPr sz="1800" b="0">
+                <a:solidFill>
+                  <a:srgbClr val="000000"/>
+                </a:solidFill>
+                <a:latin typeface="Times New Roman"/>
+              </a:defRPr>
+            </a:pPr>
+            <a:r>
+              <a:t>Frontend Stack: React 18, Vite, TailwindCSS, Axios, Lucide React Icons.</a:t>
             </a:r>
           </a:p>
         </p:txBody>
@@ -6794,7 +6704,7 @@
               </a:defRPr>
             </a:pPr>
             <a:r>
-              <a:t>SOMATIC &amp; GROUNDING CBT INTERVENTIONS</a:t>
+              <a:t>FINANCIAL UTILIZATION &amp; BUDGET SUMMARY</a:t>
             </a:r>
           </a:p>
         </p:txBody>
@@ -6833,23 +6743,71 @@
               </a:defRPr>
             </a:pPr>
             <a:r>
-              <a:t>4-7-8 Somatic Breathing:</a:t>
-            </a:r>
-          </a:p>
-          <a:p>
-            <a:pPr>
-              <a:spcAft>
-                <a:spcPts val="800"/>
-              </a:spcAft>
-              <a:defRPr sz="1800" b="0">
-                <a:solidFill>
-                  <a:srgbClr val="000000"/>
-                </a:solidFill>
-                <a:latin typeface="Times New Roman"/>
-              </a:defRPr>
-            </a:pPr>
-            <a:r>
-              <a:t>Visual pacing guide (inhale 4s, hold 7s, exhale 8s) stimulating the parasympathetic vagus nerve to lower heart rate and calm panic.</a:t>
+              <a:t>TNSDC Grant Utilization Breakdown (Max Limit: ₹15,000.00):</a:t>
+            </a:r>
+          </a:p>
+          <a:p>
+            <a:pPr>
+              <a:spcAft>
+                <a:spcPts val="800"/>
+              </a:spcAft>
+              <a:defRPr sz="1800" b="0">
+                <a:solidFill>
+                  <a:srgbClr val="000000"/>
+                </a:solidFill>
+                <a:latin typeface="Times New Roman"/>
+              </a:defRPr>
+            </a:pPr>
+            <a:r>
+              <a:t>• Item 1: 6x3ft Roll-Up Standee &amp; Hardbound Reports Printing -&gt; ₹2,500.00</a:t>
+            </a:r>
+          </a:p>
+          <a:p>
+            <a:pPr>
+              <a:spcAft>
+                <a:spcPts val="800"/>
+              </a:spcAft>
+              <a:defRPr sz="1800" b="0">
+                <a:solidFill>
+                  <a:srgbClr val="000000"/>
+                </a:solidFill>
+                <a:latin typeface="Times New Roman"/>
+              </a:defRPr>
+            </a:pPr>
+            <a:r>
+              <a:t>• Item 2: Wireless USB Microphone &amp; Presenter (Voice AI Demo) -&gt; ₹4,000.00</a:t>
+            </a:r>
+          </a:p>
+          <a:p>
+            <a:pPr>
+              <a:spcAft>
+                <a:spcPts val="800"/>
+              </a:spcAft>
+              <a:defRPr sz="1800" b="0">
+                <a:solidFill>
+                  <a:srgbClr val="000000"/>
+                </a:solidFill>
+                <a:latin typeface="Times New Roman"/>
+              </a:defRPr>
+            </a:pPr>
+            <a:r>
+              <a:t>• Item 3: Regional Review Evaluation &amp; Team Logistics Transport -&gt; ₹3,000.00</a:t>
+            </a:r>
+          </a:p>
+          <a:p>
+            <a:pPr>
+              <a:spcAft>
+                <a:spcPts val="800"/>
+              </a:spcAft>
+              <a:defRPr sz="1800" b="0">
+                <a:solidFill>
+                  <a:srgbClr val="000000"/>
+                </a:solidFill>
+                <a:latin typeface="Times New Roman"/>
+              </a:defRPr>
+            </a:pPr>
+            <a:r>
+              <a:t>• Item 4: HD Web Camera (Affective Vision &amp; Journey Video) -&gt; ₹5,500.00</a:t>
             </a:r>
           </a:p>
           <a:p>
@@ -6878,52 +6836,7 @@
               </a:defRPr>
             </a:pPr>
             <a:r>
-              <a:t>5-4-3-2-1 Sensory Grounding:</a:t>
-            </a:r>
-          </a:p>
-          <a:p>
-            <a:pPr>
-              <a:spcAft>
-                <a:spcPts val="800"/>
-              </a:spcAft>
-              <a:defRPr sz="1800" b="0">
-                <a:solidFill>
-                  <a:srgbClr val="000000"/>
-                </a:solidFill>
-                <a:latin typeface="Times New Roman"/>
-              </a:defRPr>
-            </a:pPr>
-            <a:r>
-              <a:t>Interactive exercise guiding patients to identify 5 sights, 4 touch sensations, 3 sounds, 2 smells, and 1 taste.</a:t>
-            </a:r>
-          </a:p>
-          <a:p>
-            <a:pPr>
-              <a:spcAft>
-                <a:spcPts val="800"/>
-              </a:spcAft>
-              <a:defRPr sz="1800" b="0">
-                <a:solidFill>
-                  <a:srgbClr val="000000"/>
-                </a:solidFill>
-                <a:latin typeface="Times New Roman"/>
-              </a:defRPr>
-            </a:pPr>
-          </a:p>
-          <a:p>
-            <a:pPr>
-              <a:spcAft>
-                <a:spcPts val="800"/>
-              </a:spcAft>
-              <a:defRPr sz="1800" b="0">
-                <a:solidFill>
-                  <a:srgbClr val="000000"/>
-                </a:solidFill>
-                <a:latin typeface="Times New Roman"/>
-              </a:defRPr>
-            </a:pPr>
-            <a:r>
-              <a:t>Music Sanctuary: Integrated ambient soundscapes and binaural beats for acute anxiety reduction.</a:t>
+              <a:t>Total Utilized: ₹15,000.00 | Billed to: The Director, Centre for Academic Courses, Anna University, Chennai.</a:t>
             </a:r>
           </a:p>
         </p:txBody>
@@ -7021,7 +6934,7 @@
               </a:defRPr>
             </a:pPr>
             <a:r>
-              <a:t>FINANCIAL UTILIZATION &amp; BUDGET SUMMARY</a:t>
+              <a:t>PROJECT ROADMAP &amp; EXTENSION PHASES</a:t>
             </a:r>
           </a:p>
         </p:txBody>
@@ -7060,100 +6973,55 @@
               </a:defRPr>
             </a:pPr>
             <a:r>
-              <a:t>TNSDC Grant Utilization Breakdown (Max Limit: ₹15,000.00):</a:t>
-            </a:r>
-          </a:p>
-          <a:p>
-            <a:pPr>
-              <a:spcAft>
-                <a:spcPts val="800"/>
-              </a:spcAft>
-              <a:defRPr sz="1800" b="0">
-                <a:solidFill>
-                  <a:srgbClr val="000000"/>
-                </a:solidFill>
-                <a:latin typeface="Times New Roman"/>
-              </a:defRPr>
-            </a:pPr>
-            <a:r>
-              <a:t>• Item 1: 6x3ft Roll-Up Standee &amp; Hardbound Reports Printing -&gt; ₹2,500.00</a:t>
-            </a:r>
-          </a:p>
-          <a:p>
-            <a:pPr>
-              <a:spcAft>
-                <a:spcPts val="800"/>
-              </a:spcAft>
-              <a:defRPr sz="1800" b="0">
-                <a:solidFill>
-                  <a:srgbClr val="000000"/>
-                </a:solidFill>
-                <a:latin typeface="Times New Roman"/>
-              </a:defRPr>
-            </a:pPr>
-            <a:r>
-              <a:t>• Item 2: Wireless USB Microphone &amp; Presenter (Voice AI Demo) -&gt; ₹4,000.00</a:t>
-            </a:r>
-          </a:p>
-          <a:p>
-            <a:pPr>
-              <a:spcAft>
-                <a:spcPts val="800"/>
-              </a:spcAft>
-              <a:defRPr sz="1800" b="0">
-                <a:solidFill>
-                  <a:srgbClr val="000000"/>
-                </a:solidFill>
-                <a:latin typeface="Times New Roman"/>
-              </a:defRPr>
-            </a:pPr>
-            <a:r>
-              <a:t>• Item 3: Regional Review Evaluation &amp; Team Logistics Transport -&gt; ₹3,000.00</a:t>
-            </a:r>
-          </a:p>
-          <a:p>
-            <a:pPr>
-              <a:spcAft>
-                <a:spcPts val="800"/>
-              </a:spcAft>
-              <a:defRPr sz="1800" b="0">
-                <a:solidFill>
-                  <a:srgbClr val="000000"/>
-                </a:solidFill>
-                <a:latin typeface="Times New Roman"/>
-              </a:defRPr>
-            </a:pPr>
-            <a:r>
-              <a:t>• Item 4: HD Web Camera (Affective Vision &amp; Journey Video) -&gt; ₹5,500.00</a:t>
-            </a:r>
-          </a:p>
-          <a:p>
-            <a:pPr>
-              <a:spcAft>
-                <a:spcPts val="800"/>
-              </a:spcAft>
-              <a:defRPr sz="1800" b="0">
-                <a:solidFill>
-                  <a:srgbClr val="000000"/>
-                </a:solidFill>
-                <a:latin typeface="Times New Roman"/>
-              </a:defRPr>
-            </a:pPr>
-          </a:p>
-          <a:p>
-            <a:pPr>
-              <a:spcAft>
-                <a:spcPts val="800"/>
-              </a:spcAft>
-              <a:defRPr sz="1900" b="1">
-                <a:solidFill>
-                  <a:srgbClr val="000000"/>
-                </a:solidFill>
-                <a:latin typeface="Times New Roman"/>
-              </a:defRPr>
-            </a:pPr>
-            <a:r>
-              <a:t>Total Utilized: ₹15,000.00 | Billed to: The Director, Centre for Academic Courses, Anna University, Chennai.</a:t>
+              <a:t>Phase 1 (Completed): Core Multimodal AI Brain, BERT 96-Emotion Model, &amp; 3-Tier Therapeutic Engine.</a:t>
+            </a:r>
+          </a:p>
+          <a:p>
+            <a:pPr>
+              <a:spcAft>
+                <a:spcPts val="800"/>
+              </a:spcAft>
+              <a:defRPr sz="1800" b="0">
+                <a:solidFill>
+                  <a:srgbClr val="000000"/>
+                </a:solidFill>
+                <a:latin typeface="Times New Roman"/>
+              </a:defRPr>
+            </a:pPr>
+            <a:r>
+              <a:t>Phase 2 (Completed): Admin Clinical Hub, Multimodal Video Call, SHAP XAI, &amp; HuggingFace Space Deployment.</a:t>
+            </a:r>
+          </a:p>
+          <a:p>
+            <a:pPr>
+              <a:spcAft>
+                <a:spcPts val="800"/>
+              </a:spcAft>
+              <a:defRPr sz="1800" b="0">
+                <a:solidFill>
+                  <a:srgbClr val="000000"/>
+                </a:solidFill>
+                <a:latin typeface="Times New Roman"/>
+              </a:defRPr>
+            </a:pPr>
+            <a:r>
+              <a:t>Phase 3 (Upcoming 6 Months): Wearable IoT PPG sensor integration for continuous Heart Rate Variability (HRV) tracking.</a:t>
+            </a:r>
+          </a:p>
+          <a:p>
+            <a:pPr>
+              <a:spcAft>
+                <a:spcPts val="800"/>
+              </a:spcAft>
+              <a:defRPr sz="1800" b="0">
+                <a:solidFill>
+                  <a:srgbClr val="000000"/>
+                </a:solidFill>
+                <a:latin typeface="Times New Roman"/>
+              </a:defRPr>
+            </a:pPr>
+            <a:r>
+              <a:t>Phase 4 (Upcoming 12 Months): Fine-tuning localized Tamil and regional Indian language NLP models for rural health centers.</a:t>
             </a:r>
           </a:p>
         </p:txBody>
@@ -7486,15 +7354,15 @@
           <a:lstStyle/>
           <a:p>
             <a:pPr>
-              <a:defRPr sz="2800" b="1">
-                <a:solidFill>
-                  <a:srgbClr val="000000"/>
-                </a:solidFill>
-                <a:latin typeface="Times New Roman"/>
-              </a:defRPr>
-            </a:pPr>
-            <a:r>
-              <a:t>PROBLEM STATEMENT</a:t>
+              <a:defRPr sz="2400" b="1">
+                <a:solidFill>
+                  <a:srgbClr val="000000"/>
+                </a:solidFill>
+                <a:latin typeface="Times New Roman"/>
+              </a:defRPr>
+            </a:pPr>
+            <a:r>
+              <a:t>CLINICAL PROBLEM STATEMENT: THE 167-HOUR CARE GAP</a:t>
             </a:r>
           </a:p>
         </p:txBody>
@@ -7564,19 +7432,6 @@
             <a:r>
               <a:t>Three Interconnected Challenges:</a:t>
             </a:r>
-          </a:p>
-          <a:p>
-            <a:pPr>
-              <a:spcAft>
-                <a:spcPts val="800"/>
-              </a:spcAft>
-              <a:defRPr sz="1800" b="0">
-                <a:solidFill>
-                  <a:srgbClr val="000000"/>
-                </a:solidFill>
-                <a:latin typeface="Times New Roman"/>
-              </a:defRPr>
-            </a:pPr>
           </a:p>
           <a:p>
             <a:pPr>
@@ -7787,15 +7642,15 @@
           <a:lstStyle/>
           <a:p>
             <a:pPr>
-              <a:defRPr sz="2800" b="1">
-                <a:solidFill>
-                  <a:srgbClr val="000000"/>
-                </a:solidFill>
-                <a:latin typeface="Times New Roman"/>
-              </a:defRPr>
-            </a:pPr>
-            <a:r>
-              <a:t>SOLUTION</a:t>
+              <a:defRPr sz="2400" b="1">
+                <a:solidFill>
+                  <a:srgbClr val="000000"/>
+                </a:solidFill>
+                <a:latin typeface="Times New Roman"/>
+              </a:defRPr>
+            </a:pPr>
+            <a:r>
+              <a:t>LIMITATIONS OF CURRENT DIGITAL MENTAL HEALTH SOLUTIONS</a:t>
             </a:r>
           </a:p>
         </p:txBody>
@@ -7834,87 +7689,23 @@
               </a:defRPr>
             </a:pPr>
             <a:r>
-              <a:t>Keffi AI is designed as a clinical mental health support system, not just a chatbot.</a:t>
-            </a:r>
-          </a:p>
-          <a:p>
-            <a:pPr>
-              <a:spcAft>
-                <a:spcPts val="800"/>
-              </a:spcAft>
-              <a:defRPr sz="1800" b="0">
-                <a:solidFill>
-                  <a:srgbClr val="000000"/>
-                </a:solidFill>
-                <a:latin typeface="Times New Roman"/>
-              </a:defRPr>
-            </a:pPr>
-            <a:r>
-              <a:t>It uses AI + psychological frameworks to understand user emotions and respond using scientifically validated therapeutic strategies.</a:t>
-            </a:r>
-          </a:p>
-          <a:p>
-            <a:pPr>
-              <a:spcAft>
-                <a:spcPts val="800"/>
-              </a:spcAft>
-              <a:defRPr sz="1800" b="0">
-                <a:solidFill>
-                  <a:srgbClr val="000000"/>
-                </a:solidFill>
-                <a:latin typeface="Times New Roman"/>
-              </a:defRPr>
-            </a:pPr>
-            <a:r>
-              <a:t>Instead of giving generic replies, Keffi:</a:t>
-            </a:r>
-          </a:p>
-          <a:p>
-            <a:pPr>
-              <a:spcAft>
-                <a:spcPts val="800"/>
-              </a:spcAft>
-              <a:defRPr sz="1800" b="0">
-                <a:solidFill>
-                  <a:srgbClr val="000000"/>
-                </a:solidFill>
-                <a:latin typeface="Times New Roman"/>
-              </a:defRPr>
-            </a:pPr>
-            <a:r>
-              <a:t>• Analyzes user emotion in real-time (Multimodal Sensing: Camera + Mic + BERT)</a:t>
-            </a:r>
-          </a:p>
-          <a:p>
-            <a:pPr>
-              <a:spcAft>
-                <a:spcPts val="800"/>
-              </a:spcAft>
-              <a:defRPr sz="1800" b="0">
-                <a:solidFill>
-                  <a:srgbClr val="000000"/>
-                </a:solidFill>
-                <a:latin typeface="Times New Roman"/>
-              </a:defRPr>
-            </a:pPr>
-            <a:r>
-              <a:t>• Selects the best therapeutic response type dynamically</a:t>
-            </a:r>
-          </a:p>
-          <a:p>
-            <a:pPr>
-              <a:spcAft>
-                <a:spcPts val="800"/>
-              </a:spcAft>
-              <a:defRPr sz="1800" b="0">
-                <a:solidFill>
-                  <a:srgbClr val="000000"/>
-                </a:solidFill>
-                <a:latin typeface="Times New Roman"/>
-              </a:defRPr>
-            </a:pPr>
-            <a:r>
-              <a:t>• Provides personalized, safe, and structured support</a:t>
+              <a:t>1. Rule-Based Chatbots (Examples: Woebot, Wysa)</a:t>
+            </a:r>
+          </a:p>
+          <a:p>
+            <a:pPr>
+              <a:spcAft>
+                <a:spcPts val="800"/>
+              </a:spcAft>
+              <a:defRPr sz="1800" b="0">
+                <a:solidFill>
+                  <a:srgbClr val="000000"/>
+                </a:solidFill>
+                <a:latin typeface="Times New Roman"/>
+              </a:defRPr>
+            </a:pPr>
+            <a:r>
+              <a:t>Rule-based chatbots operate on simple keyword matching with static pre-written responses. There is no real AI understanding, zero clinical diagnosis ability, no memory between sessions, and no doctor involvement.</a:t>
             </a:r>
           </a:p>
           <a:p>
@@ -7943,55 +7734,68 @@
               </a:defRPr>
             </a:pPr>
             <a:r>
-              <a:t>Core Platform Pillars:</a:t>
-            </a:r>
-          </a:p>
-          <a:p>
-            <a:pPr>
-              <a:spcAft>
-                <a:spcPts val="800"/>
-              </a:spcAft>
-              <a:defRPr sz="1800" b="0">
-                <a:solidFill>
-                  <a:srgbClr val="000000"/>
-                </a:solidFill>
-                <a:latin typeface="Times New Roman"/>
-              </a:defRPr>
-            </a:pPr>
-            <a:r>
-              <a:t>1. 24/7 Empathetic Triage &amp; Multimodal Sensing (Webcam Reticle + Mic Librosa)</a:t>
-            </a:r>
-          </a:p>
-          <a:p>
-            <a:pPr>
-              <a:spcAft>
-                <a:spcPts val="800"/>
-              </a:spcAft>
-              <a:defRPr sz="1800" b="0">
-                <a:solidFill>
-                  <a:srgbClr val="000000"/>
-                </a:solidFill>
-                <a:latin typeface="Times New Roman"/>
-              </a:defRPr>
-            </a:pPr>
-            <a:r>
-              <a:t>2. SHAP &amp; LIME Explainable AI (XAI) for Clinician Auditing</a:t>
-            </a:r>
-          </a:p>
-          <a:p>
-            <a:pPr>
-              <a:spcAft>
-                <a:spcPts val="800"/>
-              </a:spcAft>
-              <a:defRPr sz="1800" b="0">
-                <a:solidFill>
-                  <a:srgbClr val="000000"/>
-                </a:solidFill>
-                <a:latin typeface="Times New Roman"/>
-              </a:defRPr>
-            </a:pPr>
-            <a:r>
-              <a:t>3. Executive Admin Clinical Hub with One-Click Automated Doctor Booking</a:t>
+              <a:t>2. LLM Wrappers (Examples: ChatGPT-based Mental Health Bots)</a:t>
+            </a:r>
+          </a:p>
+          <a:p>
+            <a:pPr>
+              <a:spcAft>
+                <a:spcPts val="800"/>
+              </a:spcAft>
+              <a:defRPr sz="1800" b="0">
+                <a:solidFill>
+                  <a:srgbClr val="000000"/>
+                </a:solidFill>
+                <a:latin typeface="Times New Roman"/>
+              </a:defRPr>
+            </a:pPr>
+            <a:r>
+              <a:t>LLM-based mental health bots transmit un-anonymized user data directly to third-party OpenAI servers without privacy filtering. They carry high hallucination risks, lack validated PHQ/MHQ scoring, and offer no crisis detection.</a:t>
+            </a:r>
+          </a:p>
+          <a:p>
+            <a:pPr>
+              <a:spcAft>
+                <a:spcPts val="800"/>
+              </a:spcAft>
+              <a:defRPr sz="1800" b="0">
+                <a:solidFill>
+                  <a:srgbClr val="000000"/>
+                </a:solidFill>
+                <a:latin typeface="Times New Roman"/>
+              </a:defRPr>
+            </a:pPr>
+          </a:p>
+          <a:p>
+            <a:pPr>
+              <a:spcAft>
+                <a:spcPts val="800"/>
+              </a:spcAft>
+              <a:defRPr sz="1900" b="1">
+                <a:solidFill>
+                  <a:srgbClr val="000000"/>
+                </a:solidFill>
+                <a:latin typeface="Times New Roman"/>
+              </a:defRPr>
+            </a:pPr>
+            <a:r>
+              <a:t>3. Traditional Therapy Apps (Examples: BetterHelp, Talkspace)</a:t>
+            </a:r>
+          </a:p>
+          <a:p>
+            <a:pPr>
+              <a:spcAft>
+                <a:spcPts val="800"/>
+              </a:spcAft>
+              <a:defRPr sz="1800" b="0">
+                <a:solidFill>
+                  <a:srgbClr val="000000"/>
+                </a:solidFill>
+                <a:latin typeface="Times New Roman"/>
+              </a:defRPr>
+            </a:pPr>
+            <a:r>
+              <a:t>Traditional therapy platforms connect patients with human therapists at $60 to $100 per hour. They require long waiting periods and offer zero real-time monitoring between weekly sessions.</a:t>
             </a:r>
           </a:p>
         </p:txBody>
@@ -8089,7 +7893,7 @@
               </a:defRPr>
             </a:pPr>
             <a:r>
-              <a:t>KEFFI'S 7 THERAPEUTIC AI RESPONSE TYPES</a:t>
+              <a:t>RESEARCH AND SCIENTIFIC VALIDATION</a:t>
             </a:r>
           </a:p>
         </p:txBody>
@@ -8128,8 +7932,37 @@
               </a:defRPr>
             </a:pPr>
             <a:r>
-              <a:t>1. Validation &amp; Empathy: Accepts feelings without judgment (Person-Centered Therapy — 30% alliance success).</a:t>
-            </a:r>
+              <a:t>1. CBT Meta-Analysis (Hofmann et al., 2012)</a:t>
+            </a:r>
+          </a:p>
+          <a:p>
+            <a:pPr>
+              <a:spcAft>
+                <a:spcPts val="800"/>
+              </a:spcAft>
+              <a:defRPr sz="1800" b="0">
+                <a:solidFill>
+                  <a:srgbClr val="000000"/>
+                </a:solidFill>
+                <a:latin typeface="Times New Roman"/>
+              </a:defRPr>
+            </a:pPr>
+            <a:r>
+              <a:t>Meta-analysis of meta-analyses proving that Cognitive Behavioral Therapy (CBT) reframing achieves a 50-75% symptom reduction in depression and anxiety.</a:t>
+            </a:r>
+          </a:p>
+          <a:p>
+            <a:pPr>
+              <a:spcAft>
+                <a:spcPts val="800"/>
+              </a:spcAft>
+              <a:defRPr sz="1800" b="0">
+                <a:solidFill>
+                  <a:srgbClr val="000000"/>
+                </a:solidFill>
+                <a:latin typeface="Times New Roman"/>
+              </a:defRPr>
+            </a:pPr>
           </a:p>
           <a:p>
             <a:pPr>
@@ -8144,8 +7977,37 @@
               </a:defRPr>
             </a:pPr>
             <a:r>
-              <a:t>2. Metaphor &amp; Storytelling: Uses simple analogies (Acceptance &amp; Commitment Therapy / ACT — Cognitive Defusion).</a:t>
-            </a:r>
+              <a:t>2. Therapeutic Alliance &amp; Empathy (Norcross &amp; Wampold, 2011)</a:t>
+            </a:r>
+          </a:p>
+          <a:p>
+            <a:pPr>
+              <a:spcAft>
+                <a:spcPts val="800"/>
+              </a:spcAft>
+              <a:defRPr sz="1800" b="0">
+                <a:solidFill>
+                  <a:srgbClr val="000000"/>
+                </a:solidFill>
+                <a:latin typeface="Times New Roman"/>
+              </a:defRPr>
+            </a:pPr>
+            <a:r>
+              <a:t>Empirical medical research proving that person-centered empathetic validation accounts for 30% of treatment success independent of medication.</a:t>
+            </a:r>
+          </a:p>
+          <a:p>
+            <a:pPr>
+              <a:spcAft>
+                <a:spcPts val="800"/>
+              </a:spcAft>
+              <a:defRPr sz="1800" b="0">
+                <a:solidFill>
+                  <a:srgbClr val="000000"/>
+                </a:solidFill>
+                <a:latin typeface="Times New Roman"/>
+              </a:defRPr>
+            </a:pPr>
           </a:p>
           <a:p>
             <a:pPr>
@@ -8160,8 +8022,37 @@
               </a:defRPr>
             </a:pPr>
             <a:r>
-              <a:t>3. Psychoeducation &amp; Biological Framing: Explains Amygdala &amp; Cortisol science to normalize panic reactions.</a:t>
-            </a:r>
+              <a:t>3. ACT &amp; Somatic Grounding (Hayes et al., 2006)</a:t>
+            </a:r>
+          </a:p>
+          <a:p>
+            <a:pPr>
+              <a:spcAft>
+                <a:spcPts val="800"/>
+              </a:spcAft>
+              <a:defRPr sz="1800" b="0">
+                <a:solidFill>
+                  <a:srgbClr val="000000"/>
+                </a:solidFill>
+                <a:latin typeface="Times New Roman"/>
+              </a:defRPr>
+            </a:pPr>
+            <a:r>
+              <a:t>Acceptance and Commitment Therapy studies proving that 4-7-8 somatic breathing and sensory grounding reduce acute panic attacks by 45-50%.</a:t>
+            </a:r>
+          </a:p>
+          <a:p>
+            <a:pPr>
+              <a:spcAft>
+                <a:spcPts val="800"/>
+              </a:spcAft>
+              <a:defRPr sz="1800" b="0">
+                <a:solidFill>
+                  <a:srgbClr val="000000"/>
+                </a:solidFill>
+                <a:latin typeface="Times New Roman"/>
+              </a:defRPr>
+            </a:pPr>
           </a:p>
           <a:p>
             <a:pPr>
@@ -8176,55 +8067,23 @@
               </a:defRPr>
             </a:pPr>
             <a:r>
-              <a:t>4. Cognitive Reframing &amp; CBT: Identifies cognitive distortions to reframe negative thoughts (50-75% symptom drop).</a:t>
-            </a:r>
-          </a:p>
-          <a:p>
-            <a:pPr>
-              <a:spcAft>
-                <a:spcPts val="800"/>
-              </a:spcAft>
-              <a:defRPr sz="1900" b="1">
-                <a:solidFill>
-                  <a:srgbClr val="000000"/>
-                </a:solidFill>
-                <a:latin typeface="Times New Roman"/>
-              </a:defRPr>
-            </a:pPr>
-            <a:r>
-              <a:t>5. Behavioral Activation &amp; Micro-Steps: Breaks tasks into micro-steps to overcome depressive paralysis.</a:t>
-            </a:r>
-          </a:p>
-          <a:p>
-            <a:pPr>
-              <a:spcAft>
-                <a:spcPts val="800"/>
-              </a:spcAft>
-              <a:defRPr sz="1900" b="1">
-                <a:solidFill>
-                  <a:srgbClr val="000000"/>
-                </a:solidFill>
-                <a:latin typeface="Times New Roman"/>
-              </a:defRPr>
-            </a:pPr>
-            <a:r>
-              <a:t>6. Somatic &amp; Sensory Grounding: 4-7-8 breathing &amp; 5-4-3-2-1 grounding to stimulate vagus nerve balance.</a:t>
-            </a:r>
-          </a:p>
-          <a:p>
-            <a:pPr>
-              <a:spcAft>
-                <a:spcPts val="800"/>
-              </a:spcAft>
-              <a:defRPr sz="1900" b="1">
-                <a:solidFill>
-                  <a:srgbClr val="000000"/>
-                </a:solidFill>
-                <a:latin typeface="Times New Roman"/>
-              </a:defRPr>
-            </a:pPr>
-            <a:r>
-              <a:t>7. Crisis Escalation Protocol: Triggers emergency SOS overlays &amp; n8n WhatsApp/SMS webhooks (&lt;40 MHQ).</a:t>
+              <a:t>4. Columbia C-SSRS Triage (Posner et al., 2011)</a:t>
+            </a:r>
+          </a:p>
+          <a:p>
+            <a:pPr>
+              <a:spcAft>
+                <a:spcPts val="800"/>
+              </a:spcAft>
+              <a:defRPr sz="1800" b="0">
+                <a:solidFill>
+                  <a:srgbClr val="000000"/>
+                </a:solidFill>
+                <a:latin typeface="Times New Roman"/>
+              </a:defRPr>
+            </a:pPr>
+            <a:r>
+              <a:t>Clinically validated suicide triage protocol powering Keffi's automated emergency SOS and risk escalation pathways.</a:t>
             </a:r>
           </a:p>
         </p:txBody>
@@ -8322,7 +8181,7 @@
               </a:defRPr>
             </a:pPr>
             <a:r>
-              <a:t>EXISTING SYSTEM</a:t>
+              <a:t>THE STANFORD WOEBOT STUDY: CLINICAL PROOF</a:t>
             </a:r>
           </a:p>
         </p:txBody>
@@ -8361,23 +8220,23 @@
               </a:defRPr>
             </a:pPr>
             <a:r>
-              <a:t>1. Rule-Based Chatbots (Examples: Woebot, Wysa)</a:t>
-            </a:r>
-          </a:p>
-          <a:p>
-            <a:pPr>
-              <a:spcAft>
-                <a:spcPts val="800"/>
-              </a:spcAft>
-              <a:defRPr sz="1800" b="0">
-                <a:solidFill>
-                  <a:srgbClr val="000000"/>
-                </a:solidFill>
-                <a:latin typeface="Times New Roman"/>
-              </a:defRPr>
-            </a:pPr>
-            <a:r>
-              <a:t>Rule-based chatbots operate on simple keyword matching with static pre-written responses. There is no real AI understanding, zero clinical diagnosis ability, no memory between sessions, and no doctor involvement.</a:t>
+              <a:t>Stanford University RCT Study (Fitzpatrick et al., JMIR 2017)</a:t>
+            </a:r>
+          </a:p>
+          <a:p>
+            <a:pPr>
+              <a:spcAft>
+                <a:spcPts val="800"/>
+              </a:spcAft>
+              <a:defRPr sz="1800" b="0">
+                <a:solidFill>
+                  <a:srgbClr val="000000"/>
+                </a:solidFill>
+                <a:latin typeface="Times New Roman"/>
+              </a:defRPr>
+            </a:pPr>
+            <a:r>
+              <a:t>A seminal Randomized Controlled Trial evaluating fully automated conversational CBT AI agents in young adults with symptoms of depression and anxiety.</a:t>
             </a:r>
           </a:p>
           <a:p>
@@ -8406,23 +8265,39 @@
               </a:defRPr>
             </a:pPr>
             <a:r>
-              <a:t>2. LLM Wrappers (Examples: ChatGPT-based Mental Health Bots)</a:t>
-            </a:r>
-          </a:p>
-          <a:p>
-            <a:pPr>
-              <a:spcAft>
-                <a:spcPts val="800"/>
-              </a:spcAft>
-              <a:defRPr sz="1800" b="0">
-                <a:solidFill>
-                  <a:srgbClr val="000000"/>
-                </a:solidFill>
-                <a:latin typeface="Times New Roman"/>
-              </a:defRPr>
-            </a:pPr>
-            <a:r>
-              <a:t>LLM-based mental health bots transmit un-anonymized user data directly to third-party OpenAI servers without privacy filtering. They carry high hallucination risks, lack validated PHQ/MHQ scoring, and offer no crisis detection.</a:t>
+              <a:t>Key Statistically Significant Findings:</a:t>
+            </a:r>
+          </a:p>
+          <a:p>
+            <a:pPr>
+              <a:spcAft>
+                <a:spcPts val="800"/>
+              </a:spcAft>
+              <a:defRPr sz="1800" b="0">
+                <a:solidFill>
+                  <a:srgbClr val="000000"/>
+                </a:solidFill>
+                <a:latin typeface="Times New Roman"/>
+              </a:defRPr>
+            </a:pPr>
+            <a:r>
+              <a:t>• 22% Reduction in Depression Symptoms within just 2 weeks of engagement compared to control groups.</a:t>
+            </a:r>
+          </a:p>
+          <a:p>
+            <a:pPr>
+              <a:spcAft>
+                <a:spcPts val="800"/>
+              </a:spcAft>
+              <a:defRPr sz="1800" b="0">
+                <a:solidFill>
+                  <a:srgbClr val="000000"/>
+                </a:solidFill>
+                <a:latin typeface="Times New Roman"/>
+              </a:defRPr>
+            </a:pPr>
+            <a:r>
+              <a:t>• Proved that automated, evidence-based conversational therapy provides immediate cognitive reframing that lowers clinical distress.</a:t>
             </a:r>
           </a:p>
           <a:p>
@@ -8451,23 +8326,23 @@
               </a:defRPr>
             </a:pPr>
             <a:r>
-              <a:t>3. Traditional Therapy Apps (Examples: BetterHelp, Talkspace)</a:t>
-            </a:r>
-          </a:p>
-          <a:p>
-            <a:pPr>
-              <a:spcAft>
-                <a:spcPts val="800"/>
-              </a:spcAft>
-              <a:defRPr sz="1800" b="0">
-                <a:solidFill>
-                  <a:srgbClr val="000000"/>
-                </a:solidFill>
-                <a:latin typeface="Times New Roman"/>
-              </a:defRPr>
-            </a:pPr>
-            <a:r>
-              <a:t>Traditional therapy platforms connect patients with human therapists at $60 to $100 per hour. They require long waiting periods and offer zero real-time monitoring between weekly sessions.</a:t>
+              <a:t>Keffi's Technological Advancement:</a:t>
+            </a:r>
+          </a:p>
+          <a:p>
+            <a:pPr>
+              <a:spcAft>
+                <a:spcPts val="800"/>
+              </a:spcAft>
+              <a:defRPr sz="1800" b="0">
+                <a:solidFill>
+                  <a:srgbClr val="000000"/>
+                </a:solidFill>
+                <a:latin typeface="Times New Roman"/>
+              </a:defRPr>
+            </a:pPr>
+            <a:r>
+              <a:t>Keffi AI builds upon this clinical proof by upgrading text-only conversational agents to a multimodal platform featuring camera facial vision, acoustic voice prosody, and clinician XAI heatmaps.</a:t>
             </a:r>
           </a:p>
         </p:txBody>
@@ -8565,7 +8440,7 @@
               </a:defRPr>
             </a:pPr>
             <a:r>
-              <a:t>RESEARCH AND SCIENTIFIC VALIDATION</a:t>
+              <a:t>LITERATURE SURVEY BENCHMARK MATRIX</a:t>
             </a:r>
           </a:p>
         </p:txBody>
@@ -8596,6 +8471,54 @@
               <a:spcAft>
                 <a:spcPts val="800"/>
               </a:spcAft>
+              <a:defRPr sz="1800" b="0">
+                <a:solidFill>
+                  <a:srgbClr val="000000"/>
+                </a:solidFill>
+                <a:latin typeface="Times New Roman"/>
+              </a:defRPr>
+            </a:pPr>
+            <a:r>
+              <a:t>• Woebot (JMIR 2017): Automated CBT chatbot | Limitation: Rigid decision trees with zero voice prosody, camera facial reticle, or clinician XAI.</a:t>
+            </a:r>
+          </a:p>
+          <a:p>
+            <a:pPr>
+              <a:spcAft>
+                <a:spcPts val="800"/>
+              </a:spcAft>
+              <a:defRPr sz="1800" b="0">
+                <a:solidFill>
+                  <a:srgbClr val="000000"/>
+                </a:solidFill>
+                <a:latin typeface="Times New Roman"/>
+              </a:defRPr>
+            </a:pPr>
+            <a:r>
+              <a:t>• Wysa (2020): Conversational agent | Limitation: Rule-bound scripts without automated doctor appointment booking or clinician auditing.</a:t>
+            </a:r>
+          </a:p>
+          <a:p>
+            <a:pPr>
+              <a:spcAft>
+                <a:spcPts val="800"/>
+              </a:spcAft>
+              <a:defRPr sz="1800" b="0">
+                <a:solidFill>
+                  <a:srgbClr val="000000"/>
+                </a:solidFill>
+                <a:latin typeface="Times New Roman"/>
+              </a:defRPr>
+            </a:pPr>
+            <a:r>
+              <a:t>• Youper (2021): Mind-monitoring app | Limitation: Proprietary black-box LLM without transparent SHAP/LIME attribution heatmaps.</a:t>
+            </a:r>
+          </a:p>
+          <a:p>
+            <a:pPr>
+              <a:spcAft>
+                <a:spcPts val="800"/>
+              </a:spcAft>
               <a:defRPr sz="1900" b="1">
                 <a:solidFill>
                   <a:srgbClr val="000000"/>
@@ -8604,158 +8527,7 @@
               </a:defRPr>
             </a:pPr>
             <a:r>
-              <a:t>1. CBT Meta-Analysis (Hofmann et al., 2012)</a:t>
-            </a:r>
-          </a:p>
-          <a:p>
-            <a:pPr>
-              <a:spcAft>
-                <a:spcPts val="800"/>
-              </a:spcAft>
-              <a:defRPr sz="1800" b="0">
-                <a:solidFill>
-                  <a:srgbClr val="000000"/>
-                </a:solidFill>
-                <a:latin typeface="Times New Roman"/>
-              </a:defRPr>
-            </a:pPr>
-            <a:r>
-              <a:t>Meta-analysis of meta-analyses proving that Cognitive Behavioral Therapy (CBT) reframing achieves a 50-75% symptom reduction in depression and anxiety.</a:t>
-            </a:r>
-          </a:p>
-          <a:p>
-            <a:pPr>
-              <a:spcAft>
-                <a:spcPts val="800"/>
-              </a:spcAft>
-              <a:defRPr sz="1800" b="0">
-                <a:solidFill>
-                  <a:srgbClr val="000000"/>
-                </a:solidFill>
-                <a:latin typeface="Times New Roman"/>
-              </a:defRPr>
-            </a:pPr>
-          </a:p>
-          <a:p>
-            <a:pPr>
-              <a:spcAft>
-                <a:spcPts val="800"/>
-              </a:spcAft>
-              <a:defRPr sz="1900" b="1">
-                <a:solidFill>
-                  <a:srgbClr val="000000"/>
-                </a:solidFill>
-                <a:latin typeface="Times New Roman"/>
-              </a:defRPr>
-            </a:pPr>
-            <a:r>
-              <a:t>2. Therapeutic Alliance &amp; Empathy (Norcross &amp; Wampold, 2011)</a:t>
-            </a:r>
-          </a:p>
-          <a:p>
-            <a:pPr>
-              <a:spcAft>
-                <a:spcPts val="800"/>
-              </a:spcAft>
-              <a:defRPr sz="1800" b="0">
-                <a:solidFill>
-                  <a:srgbClr val="000000"/>
-                </a:solidFill>
-                <a:latin typeface="Times New Roman"/>
-              </a:defRPr>
-            </a:pPr>
-            <a:r>
-              <a:t>Empirical medical research proving that person-centered empathetic validation accounts for 30% of treatment success independent of medication.</a:t>
-            </a:r>
-          </a:p>
-          <a:p>
-            <a:pPr>
-              <a:spcAft>
-                <a:spcPts val="800"/>
-              </a:spcAft>
-              <a:defRPr sz="1800" b="0">
-                <a:solidFill>
-                  <a:srgbClr val="000000"/>
-                </a:solidFill>
-                <a:latin typeface="Times New Roman"/>
-              </a:defRPr>
-            </a:pPr>
-          </a:p>
-          <a:p>
-            <a:pPr>
-              <a:spcAft>
-                <a:spcPts val="800"/>
-              </a:spcAft>
-              <a:defRPr sz="1900" b="1">
-                <a:solidFill>
-                  <a:srgbClr val="000000"/>
-                </a:solidFill>
-                <a:latin typeface="Times New Roman"/>
-              </a:defRPr>
-            </a:pPr>
-            <a:r>
-              <a:t>3. ACT &amp; Somatic Grounding (Hayes et al., 2006)</a:t>
-            </a:r>
-          </a:p>
-          <a:p>
-            <a:pPr>
-              <a:spcAft>
-                <a:spcPts val="800"/>
-              </a:spcAft>
-              <a:defRPr sz="1800" b="0">
-                <a:solidFill>
-                  <a:srgbClr val="000000"/>
-                </a:solidFill>
-                <a:latin typeface="Times New Roman"/>
-              </a:defRPr>
-            </a:pPr>
-            <a:r>
-              <a:t>Acceptance and Commitment Therapy studies proving that 4-7-8 somatic breathing and sensory grounding reduce acute panic attacks by 45-50%.</a:t>
-            </a:r>
-          </a:p>
-          <a:p>
-            <a:pPr>
-              <a:spcAft>
-                <a:spcPts val="800"/>
-              </a:spcAft>
-              <a:defRPr sz="1800" b="0">
-                <a:solidFill>
-                  <a:srgbClr val="000000"/>
-                </a:solidFill>
-                <a:latin typeface="Times New Roman"/>
-              </a:defRPr>
-            </a:pPr>
-          </a:p>
-          <a:p>
-            <a:pPr>
-              <a:spcAft>
-                <a:spcPts val="800"/>
-              </a:spcAft>
-              <a:defRPr sz="1900" b="1">
-                <a:solidFill>
-                  <a:srgbClr val="000000"/>
-                </a:solidFill>
-                <a:latin typeface="Times New Roman"/>
-              </a:defRPr>
-            </a:pPr>
-            <a:r>
-              <a:t>4. Columbia C-SSRS Triage (Posner et al., 2011)</a:t>
-            </a:r>
-          </a:p>
-          <a:p>
-            <a:pPr>
-              <a:spcAft>
-                <a:spcPts val="800"/>
-              </a:spcAft>
-              <a:defRPr sz="1800" b="0">
-                <a:solidFill>
-                  <a:srgbClr val="000000"/>
-                </a:solidFill>
-                <a:latin typeface="Times New Roman"/>
-              </a:defRPr>
-            </a:pPr>
-            <a:r>
-              <a:t>Clinically validated suicide triage protocol powering Keffi's automated emergency SOS and risk escalation pathways.</a:t>
+              <a:t>• Keffi AI (2026 Innovation): Industry-first multimodal platform uniting HD facial Reticle vision, Librosa voice prosody, SHAP XAI, and n8n crisis automation.</a:t>
             </a:r>
           </a:p>
         </p:txBody>
@@ -8853,7 +8625,7 @@
               </a:defRPr>
             </a:pPr>
             <a:r>
-              <a:t>THE STANFORD WOEBOT STUDY: CLINICAL PROOF</a:t>
+              <a:t>PROPOSED SOLUTION: KEFFI PLATFORM</a:t>
             </a:r>
           </a:p>
         </p:txBody>
@@ -8892,23 +8664,87 @@
               </a:defRPr>
             </a:pPr>
             <a:r>
-              <a:t>Stanford University RCT Study (Fitzpatrick et al., JMIR 2017)</a:t>
-            </a:r>
-          </a:p>
-          <a:p>
-            <a:pPr>
-              <a:spcAft>
-                <a:spcPts val="800"/>
-              </a:spcAft>
-              <a:defRPr sz="1800" b="0">
-                <a:solidFill>
-                  <a:srgbClr val="000000"/>
-                </a:solidFill>
-                <a:latin typeface="Times New Roman"/>
-              </a:defRPr>
-            </a:pPr>
-            <a:r>
-              <a:t>A seminal Randomized Controlled Trial evaluating fully automated conversational CBT AI agents in young adults with symptoms of depression and anxiety.</a:t>
+              <a:t>Keffi AI is designed as a clinical mental health support system, not just a chatbot.</a:t>
+            </a:r>
+          </a:p>
+          <a:p>
+            <a:pPr>
+              <a:spcAft>
+                <a:spcPts val="800"/>
+              </a:spcAft>
+              <a:defRPr sz="1800" b="0">
+                <a:solidFill>
+                  <a:srgbClr val="000000"/>
+                </a:solidFill>
+                <a:latin typeface="Times New Roman"/>
+              </a:defRPr>
+            </a:pPr>
+            <a:r>
+              <a:t>It uses AI + psychological frameworks to understand user emotions and respond using scientifically validated therapeutic strategies.</a:t>
+            </a:r>
+          </a:p>
+          <a:p>
+            <a:pPr>
+              <a:spcAft>
+                <a:spcPts val="800"/>
+              </a:spcAft>
+              <a:defRPr sz="1800" b="0">
+                <a:solidFill>
+                  <a:srgbClr val="000000"/>
+                </a:solidFill>
+                <a:latin typeface="Times New Roman"/>
+              </a:defRPr>
+            </a:pPr>
+            <a:r>
+              <a:t>Instead of giving generic replies, Keffi:</a:t>
+            </a:r>
+          </a:p>
+          <a:p>
+            <a:pPr>
+              <a:spcAft>
+                <a:spcPts val="800"/>
+              </a:spcAft>
+              <a:defRPr sz="1800" b="0">
+                <a:solidFill>
+                  <a:srgbClr val="000000"/>
+                </a:solidFill>
+                <a:latin typeface="Times New Roman"/>
+              </a:defRPr>
+            </a:pPr>
+            <a:r>
+              <a:t>• Analyzes user emotion in real-time (Multimodal Sensing: Camera + Mic + BERT)</a:t>
+            </a:r>
+          </a:p>
+          <a:p>
+            <a:pPr>
+              <a:spcAft>
+                <a:spcPts val="800"/>
+              </a:spcAft>
+              <a:defRPr sz="1800" b="0">
+                <a:solidFill>
+                  <a:srgbClr val="000000"/>
+                </a:solidFill>
+                <a:latin typeface="Times New Roman"/>
+              </a:defRPr>
+            </a:pPr>
+            <a:r>
+              <a:t>• Selects the best therapeutic response type dynamically</a:t>
+            </a:r>
+          </a:p>
+          <a:p>
+            <a:pPr>
+              <a:spcAft>
+                <a:spcPts val="800"/>
+              </a:spcAft>
+              <a:defRPr sz="1800" b="0">
+                <a:solidFill>
+                  <a:srgbClr val="000000"/>
+                </a:solidFill>
+                <a:latin typeface="Times New Roman"/>
+              </a:defRPr>
+            </a:pPr>
+            <a:r>
+              <a:t>• Provides personalized, safe, and structured support</a:t>
             </a:r>
           </a:p>
           <a:p>
@@ -8937,84 +8773,55 @@
               </a:defRPr>
             </a:pPr>
             <a:r>
-              <a:t>Key Statistically Significant Findings:</a:t>
-            </a:r>
-          </a:p>
-          <a:p>
-            <a:pPr>
-              <a:spcAft>
-                <a:spcPts val="800"/>
-              </a:spcAft>
-              <a:defRPr sz="1800" b="0">
-                <a:solidFill>
-                  <a:srgbClr val="000000"/>
-                </a:solidFill>
-                <a:latin typeface="Times New Roman"/>
-              </a:defRPr>
-            </a:pPr>
-            <a:r>
-              <a:t>• 22% Reduction in Depression Symptoms within just 2 weeks of engagement compared to control groups.</a:t>
-            </a:r>
-          </a:p>
-          <a:p>
-            <a:pPr>
-              <a:spcAft>
-                <a:spcPts val="800"/>
-              </a:spcAft>
-              <a:defRPr sz="1800" b="0">
-                <a:solidFill>
-                  <a:srgbClr val="000000"/>
-                </a:solidFill>
-                <a:latin typeface="Times New Roman"/>
-              </a:defRPr>
-            </a:pPr>
-            <a:r>
-              <a:t>• Proved that automated, evidence-based conversational therapy provides immediate cognitive reframing that lowers clinical distress.</a:t>
-            </a:r>
-          </a:p>
-          <a:p>
-            <a:pPr>
-              <a:spcAft>
-                <a:spcPts val="800"/>
-              </a:spcAft>
-              <a:defRPr sz="1800" b="0">
-                <a:solidFill>
-                  <a:srgbClr val="000000"/>
-                </a:solidFill>
-                <a:latin typeface="Times New Roman"/>
-              </a:defRPr>
-            </a:pPr>
-          </a:p>
-          <a:p>
-            <a:pPr>
-              <a:spcAft>
-                <a:spcPts val="800"/>
-              </a:spcAft>
-              <a:defRPr sz="1900" b="1">
-                <a:solidFill>
-                  <a:srgbClr val="000000"/>
-                </a:solidFill>
-                <a:latin typeface="Times New Roman"/>
-              </a:defRPr>
-            </a:pPr>
-            <a:r>
-              <a:t>Keffi's Technological Advancement:</a:t>
-            </a:r>
-          </a:p>
-          <a:p>
-            <a:pPr>
-              <a:spcAft>
-                <a:spcPts val="800"/>
-              </a:spcAft>
-              <a:defRPr sz="1800" b="0">
-                <a:solidFill>
-                  <a:srgbClr val="000000"/>
-                </a:solidFill>
-                <a:latin typeface="Times New Roman"/>
-              </a:defRPr>
-            </a:pPr>
-            <a:r>
-              <a:t>Keffi AI builds upon this clinical proof by upgrading text-only conversational agents to a multimodal platform featuring camera facial vision, acoustic voice prosody, and clinician XAI heatmaps.</a:t>
+              <a:t>Core Platform Pillars:</a:t>
+            </a:r>
+          </a:p>
+          <a:p>
+            <a:pPr>
+              <a:spcAft>
+                <a:spcPts val="800"/>
+              </a:spcAft>
+              <a:defRPr sz="1800" b="0">
+                <a:solidFill>
+                  <a:srgbClr val="000000"/>
+                </a:solidFill>
+                <a:latin typeface="Times New Roman"/>
+              </a:defRPr>
+            </a:pPr>
+            <a:r>
+              <a:t>1. 24/7 Empathetic Triage &amp; Multimodal Sensing (Webcam Reticle + Mic Librosa)</a:t>
+            </a:r>
+          </a:p>
+          <a:p>
+            <a:pPr>
+              <a:spcAft>
+                <a:spcPts val="800"/>
+              </a:spcAft>
+              <a:defRPr sz="1800" b="0">
+                <a:solidFill>
+                  <a:srgbClr val="000000"/>
+                </a:solidFill>
+                <a:latin typeface="Times New Roman"/>
+              </a:defRPr>
+            </a:pPr>
+            <a:r>
+              <a:t>2. SHAP &amp; LIME Explainable AI (XAI) for Clinician Auditing</a:t>
+            </a:r>
+          </a:p>
+          <a:p>
+            <a:pPr>
+              <a:spcAft>
+                <a:spcPts val="800"/>
+              </a:spcAft>
+              <a:defRPr sz="1800" b="0">
+                <a:solidFill>
+                  <a:srgbClr val="000000"/>
+                </a:solidFill>
+                <a:latin typeface="Times New Roman"/>
+              </a:defRPr>
+            </a:pPr>
+            <a:r>
+              <a:t>3. Executive Admin Clinical Hub with One-Click Automated Doctor Booking</a:t>
             </a:r>
           </a:p>
         </p:txBody>
@@ -9112,7 +8919,7 @@
               </a:defRPr>
             </a:pPr>
             <a:r>
-              <a:t>LITERATURE SURVEY BENCHMARK MATRIX</a:t>
+              <a:t>KEFFI'S 7 THERAPEUTIC AI RESPONSE TYPES</a:t>
             </a:r>
           </a:p>
         </p:txBody>
@@ -9143,54 +8950,6 @@
               <a:spcAft>
                 <a:spcPts val="800"/>
               </a:spcAft>
-              <a:defRPr sz="1800" b="0">
-                <a:solidFill>
-                  <a:srgbClr val="000000"/>
-                </a:solidFill>
-                <a:latin typeface="Times New Roman"/>
-              </a:defRPr>
-            </a:pPr>
-            <a:r>
-              <a:t>• Woebot (JMIR 2017): Automated CBT chatbot | Limitation: Rigid decision trees with zero voice prosody, camera facial reticle, or clinician XAI.</a:t>
-            </a:r>
-          </a:p>
-          <a:p>
-            <a:pPr>
-              <a:spcAft>
-                <a:spcPts val="800"/>
-              </a:spcAft>
-              <a:defRPr sz="1800" b="0">
-                <a:solidFill>
-                  <a:srgbClr val="000000"/>
-                </a:solidFill>
-                <a:latin typeface="Times New Roman"/>
-              </a:defRPr>
-            </a:pPr>
-            <a:r>
-              <a:t>• Wysa (2020): Conversational agent | Limitation: Rule-bound scripts without automated doctor appointment booking or clinician auditing.</a:t>
-            </a:r>
-          </a:p>
-          <a:p>
-            <a:pPr>
-              <a:spcAft>
-                <a:spcPts val="800"/>
-              </a:spcAft>
-              <a:defRPr sz="1800" b="0">
-                <a:solidFill>
-                  <a:srgbClr val="000000"/>
-                </a:solidFill>
-                <a:latin typeface="Times New Roman"/>
-              </a:defRPr>
-            </a:pPr>
-            <a:r>
-              <a:t>• Youper (2021): Mind-monitoring app | Limitation: Proprietary black-box LLM without transparent SHAP/LIME attribution heatmaps.</a:t>
-            </a:r>
-          </a:p>
-          <a:p>
-            <a:pPr>
-              <a:spcAft>
-                <a:spcPts val="800"/>
-              </a:spcAft>
               <a:defRPr sz="1900" b="1">
                 <a:solidFill>
                   <a:srgbClr val="000000"/>
@@ -9199,7 +8958,103 @@
               </a:defRPr>
             </a:pPr>
             <a:r>
-              <a:t>• Keffi AI (2026 Innovation): Industry-first multimodal platform uniting HD facial Reticle vision, Librosa voice prosody, SHAP XAI, and n8n crisis automation.</a:t>
+              <a:t>1. Validation &amp; Empathy: Accepts feelings without judgment (Person-Centered Therapy — 30% alliance success).</a:t>
+            </a:r>
+          </a:p>
+          <a:p>
+            <a:pPr>
+              <a:spcAft>
+                <a:spcPts val="800"/>
+              </a:spcAft>
+              <a:defRPr sz="1900" b="1">
+                <a:solidFill>
+                  <a:srgbClr val="000000"/>
+                </a:solidFill>
+                <a:latin typeface="Times New Roman"/>
+              </a:defRPr>
+            </a:pPr>
+            <a:r>
+              <a:t>2. Metaphor &amp; Storytelling: Uses simple analogies (Acceptance &amp; Commitment Therapy / ACT — Cognitive Defusion).</a:t>
+            </a:r>
+          </a:p>
+          <a:p>
+            <a:pPr>
+              <a:spcAft>
+                <a:spcPts val="800"/>
+              </a:spcAft>
+              <a:defRPr sz="1900" b="1">
+                <a:solidFill>
+                  <a:srgbClr val="000000"/>
+                </a:solidFill>
+                <a:latin typeface="Times New Roman"/>
+              </a:defRPr>
+            </a:pPr>
+            <a:r>
+              <a:t>3. Psychoeducation &amp; Biological Framing: Explains Amygdala &amp; Cortisol science to normalize panic reactions.</a:t>
+            </a:r>
+          </a:p>
+          <a:p>
+            <a:pPr>
+              <a:spcAft>
+                <a:spcPts val="800"/>
+              </a:spcAft>
+              <a:defRPr sz="1900" b="1">
+                <a:solidFill>
+                  <a:srgbClr val="000000"/>
+                </a:solidFill>
+                <a:latin typeface="Times New Roman"/>
+              </a:defRPr>
+            </a:pPr>
+            <a:r>
+              <a:t>4. Cognitive Reframing &amp; CBT: Identifies cognitive distortions to reframe negative thoughts (50-75% symptom drop).</a:t>
+            </a:r>
+          </a:p>
+          <a:p>
+            <a:pPr>
+              <a:spcAft>
+                <a:spcPts val="800"/>
+              </a:spcAft>
+              <a:defRPr sz="1900" b="1">
+                <a:solidFill>
+                  <a:srgbClr val="000000"/>
+                </a:solidFill>
+                <a:latin typeface="Times New Roman"/>
+              </a:defRPr>
+            </a:pPr>
+            <a:r>
+              <a:t>5. Behavioral Activation &amp; Micro-Steps: Breaks tasks into micro-steps to overcome depressive paralysis.</a:t>
+            </a:r>
+          </a:p>
+          <a:p>
+            <a:pPr>
+              <a:spcAft>
+                <a:spcPts val="800"/>
+              </a:spcAft>
+              <a:defRPr sz="1900" b="1">
+                <a:solidFill>
+                  <a:srgbClr val="000000"/>
+                </a:solidFill>
+                <a:latin typeface="Times New Roman"/>
+              </a:defRPr>
+            </a:pPr>
+            <a:r>
+              <a:t>6. Somatic &amp; Sensory Grounding: 4-7-8 breathing &amp; 5-4-3-2-1 grounding to stimulate vagus nerve balance.</a:t>
+            </a:r>
+          </a:p>
+          <a:p>
+            <a:pPr>
+              <a:spcAft>
+                <a:spcPts val="800"/>
+              </a:spcAft>
+              <a:defRPr sz="1900" b="1">
+                <a:solidFill>
+                  <a:srgbClr val="000000"/>
+                </a:solidFill>
+                <a:latin typeface="Times New Roman"/>
+              </a:defRPr>
+            </a:pPr>
+            <a:r>
+              <a:t>7. Crisis Escalation Protocol: Triggers emergency SOS overlays &amp; n8n WhatsApp/SMS webhooks (&lt;40 MHQ).</a:t>
             </a:r>
           </a:p>
         </p:txBody>

</xml_diff>